<commit_message>
That's what I call a "major cleanup". Looks like I made some progress to force HUGO to do what I want. Refactored site structure, added some content (starting with components)
</commit_message>
<xml_diff>
--- a/documentation/DIY-Pedalboard_01-11.pptx
+++ b/documentation/DIY-Pedalboard_01-11.pptx
@@ -5,7 +5,7 @@
     <p:sldMasterId id="2147483661" r:id="rId1"/>
   </p:sldMasterIdLst>
   <p:notesMasterIdLst>
-    <p:notesMasterId r:id="rId14"/>
+    <p:notesMasterId r:id="rId15"/>
   </p:notesMasterIdLst>
   <p:sldIdLst>
     <p:sldId id="256" r:id="rId2"/>
@@ -20,21 +20,22 @@
     <p:sldId id="297" r:id="rId11"/>
     <p:sldId id="298" r:id="rId12"/>
     <p:sldId id="299" r:id="rId13"/>
+    <p:sldId id="300" r:id="rId14"/>
   </p:sldIdLst>
   <p:sldSz cx="18288000" cy="10287000"/>
   <p:notesSz cx="6858000" cy="9144000"/>
   <p:embeddedFontLst>
     <p:embeddedFont>
       <p:font typeface="Oswald" pitchFamily="2" charset="77"/>
-      <p:regular r:id="rId15"/>
-      <p:bold r:id="rId16"/>
+      <p:regular r:id="rId16"/>
+      <p:bold r:id="rId17"/>
     </p:embeddedFont>
     <p:embeddedFont>
       <p:font typeface="Titillium Web" pitchFamily="2" charset="77"/>
-      <p:regular r:id="rId17"/>
-      <p:bold r:id="rId18"/>
-      <p:italic r:id="rId19"/>
-      <p:boldItalic r:id="rId20"/>
+      <p:regular r:id="rId18"/>
+      <p:bold r:id="rId19"/>
+      <p:italic r:id="rId20"/>
+      <p:boldItalic r:id="rId21"/>
     </p:embeddedFont>
   </p:embeddedFontLst>
   <p:defaultTextStyle>
@@ -1202,6 +1203,133 @@
     <p:extLst>
       <p:ext uri="{BB962C8B-B14F-4D97-AF65-F5344CB8AC3E}">
         <p14:creationId xmlns:p14="http://schemas.microsoft.com/office/powerpoint/2010/main" val="3569495537"/>
+      </p:ext>
+    </p:extLst>
+  </p:cSld>
+  <p:clrMapOvr>
+    <a:masterClrMapping/>
+  </p:clrMapOvr>
+</p:notes>
+</file>
+
+<file path=ppt/notesSlides/notesSlide13.xml><?xml version="1.0" encoding="utf-8"?>
+<p:notes xmlns:a="http://schemas.openxmlformats.org/drawingml/2006/main" xmlns:r="http://schemas.openxmlformats.org/officeDocument/2006/relationships" xmlns:p="http://schemas.openxmlformats.org/presentationml/2006/main" showMasterSp="0" showMasterPhAnim="0">
+  <p:cSld>
+    <p:spTree>
+      <p:nvGrpSpPr>
+        <p:cNvPr id="1" name="Shape 140">
+          <a:extLst>
+            <a:ext uri="{FF2B5EF4-FFF2-40B4-BE49-F238E27FC236}">
+              <a16:creationId xmlns:a16="http://schemas.microsoft.com/office/drawing/2014/main" id="{C2A5225A-E61F-00F9-5B6E-89D3C81C321B}"/>
+            </a:ext>
+          </a:extLst>
+        </p:cNvPr>
+        <p:cNvGrpSpPr/>
+        <p:nvPr/>
+      </p:nvGrpSpPr>
+      <p:grpSpPr>
+        <a:xfrm>
+          <a:off x="0" y="0"/>
+          <a:ext cx="0" cy="0"/>
+          <a:chOff x="0" y="0"/>
+          <a:chExt cx="0" cy="0"/>
+        </a:xfrm>
+      </p:grpSpPr>
+      <p:sp>
+        <p:nvSpPr>
+          <p:cNvPr id="141" name="Google Shape;141;p2:notes">
+            <a:extLst>
+              <a:ext uri="{FF2B5EF4-FFF2-40B4-BE49-F238E27FC236}">
+                <a16:creationId xmlns:a16="http://schemas.microsoft.com/office/drawing/2014/main" id="{BE1EADCB-6657-B37F-C4B1-64DD489E7741}"/>
+              </a:ext>
+            </a:extLst>
+          </p:cNvPr>
+          <p:cNvSpPr txBox="1">
+            <a:spLocks noGrp="1"/>
+          </p:cNvSpPr>
+          <p:nvPr>
+            <p:ph type="body" idx="1"/>
+          </p:nvPr>
+        </p:nvSpPr>
+        <p:spPr>
+          <a:xfrm>
+            <a:off x="685800" y="4343400"/>
+            <a:ext cx="5486400" cy="4114800"/>
+          </a:xfrm>
+          <a:prstGeom prst="rect">
+            <a:avLst/>
+          </a:prstGeom>
+        </p:spPr>
+        <p:txBody>
+          <a:bodyPr spcFirstLastPara="1" wrap="square" lIns="91425" tIns="91425" rIns="91425" bIns="91425" anchor="t" anchorCtr="0">
+            <a:noAutofit/>
+          </a:bodyPr>
+          <a:lstStyle/>
+          <a:p>
+            <a:pPr marL="0" lvl="0" indent="0" algn="l" rtl="0">
+              <a:spcBef>
+                <a:spcPts val="0"/>
+              </a:spcBef>
+              <a:spcAft>
+                <a:spcPts val="0"/>
+              </a:spcAft>
+              <a:buNone/>
+            </a:pPr>
+            <a:endParaRPr/>
+          </a:p>
+        </p:txBody>
+      </p:sp>
+      <p:sp>
+        <p:nvSpPr>
+          <p:cNvPr id="142" name="Google Shape;142;p2:notes">
+            <a:extLst>
+              <a:ext uri="{FF2B5EF4-FFF2-40B4-BE49-F238E27FC236}">
+                <a16:creationId xmlns:a16="http://schemas.microsoft.com/office/drawing/2014/main" id="{820EFB73-FF70-3F7C-B714-F5F1514A45C6}"/>
+              </a:ext>
+            </a:extLst>
+          </p:cNvPr>
+          <p:cNvSpPr>
+            <a:spLocks noGrp="1" noRot="1" noChangeAspect="1"/>
+          </p:cNvSpPr>
+          <p:nvPr>
+            <p:ph type="sldImg" idx="2"/>
+          </p:nvPr>
+        </p:nvSpPr>
+        <p:spPr>
+          <a:xfrm>
+            <a:off x="381000" y="685800"/>
+            <a:ext cx="6096000" cy="3429000"/>
+          </a:xfrm>
+          <a:custGeom>
+            <a:avLst/>
+            <a:gdLst/>
+            <a:ahLst/>
+            <a:cxnLst/>
+            <a:rect l="l" t="t" r="r" b="b"/>
+            <a:pathLst>
+              <a:path w="120000" h="120000" extrusionOk="0">
+                <a:moveTo>
+                  <a:pt x="0" y="0"/>
+                </a:moveTo>
+                <a:lnTo>
+                  <a:pt x="120000" y="0"/>
+                </a:lnTo>
+                <a:lnTo>
+                  <a:pt x="120000" y="120000"/>
+                </a:lnTo>
+                <a:lnTo>
+                  <a:pt x="0" y="120000"/>
+                </a:lnTo>
+                <a:close/>
+              </a:path>
+            </a:pathLst>
+          </a:custGeom>
+        </p:spPr>
+      </p:sp>
+    </p:spTree>
+    <p:extLst>
+      <p:ext uri="{BB962C8B-B14F-4D97-AF65-F5344CB8AC3E}">
+        <p14:creationId xmlns:p14="http://schemas.microsoft.com/office/powerpoint/2010/main" val="986997167"/>
       </p:ext>
     </p:extLst>
   </p:cSld>
@@ -17090,13 +17218,13 @@
   <p:clrMapOvr>
     <a:masterClrMapping/>
   </p:clrMapOvr>
-  <mc:AlternateContent xmlns:mc="http://schemas.openxmlformats.org/markup-compatibility/2006">
-    <mc:Choice xmlns:p159="http://schemas.microsoft.com/office/powerpoint/2015/09/main" Requires="p159">
+  <mc:AlternateContent xmlns:mc="http://schemas.openxmlformats.org/markup-compatibility/2006" xmlns:p159="http://schemas.microsoft.com/office/powerpoint/2015/09/main">
+    <mc:Choice Requires="p159">
       <p:transition xmlns:p14="http://schemas.microsoft.com/office/powerpoint/2010/main" spd="slow" p14:dur="2000">
         <p159:morph option="byObject"/>
       </p:transition>
     </mc:Choice>
-    <mc:Fallback>
+    <mc:Fallback xmlns="">
       <p:transition spd="slow">
         <p:fade/>
       </p:transition>
@@ -19147,13 +19275,13 @@
   <p:clrMapOvr>
     <a:masterClrMapping/>
   </p:clrMapOvr>
-  <mc:AlternateContent xmlns:mc="http://schemas.openxmlformats.org/markup-compatibility/2006">
-    <mc:Choice xmlns:p159="http://schemas.microsoft.com/office/powerpoint/2015/09/main" Requires="p159">
+  <mc:AlternateContent xmlns:mc="http://schemas.openxmlformats.org/markup-compatibility/2006" xmlns:p159="http://schemas.microsoft.com/office/powerpoint/2015/09/main">
+    <mc:Choice Requires="p159">
       <p:transition xmlns:p14="http://schemas.microsoft.com/office/powerpoint/2010/main" spd="slow" p14:dur="2000">
         <p159:morph option="byObject"/>
       </p:transition>
     </mc:Choice>
-    <mc:Fallback>
+    <mc:Fallback xmlns="">
       <p:transition spd="slow">
         <p:fade/>
       </p:transition>
@@ -20852,13 +20980,1625 @@
   <p:clrMapOvr>
     <a:masterClrMapping/>
   </p:clrMapOvr>
-  <mc:AlternateContent xmlns:mc="http://schemas.openxmlformats.org/markup-compatibility/2006">
-    <mc:Choice xmlns:p159="http://schemas.microsoft.com/office/powerpoint/2015/09/main" Requires="p159">
+  <mc:AlternateContent xmlns:mc="http://schemas.openxmlformats.org/markup-compatibility/2006" xmlns:p159="http://schemas.microsoft.com/office/powerpoint/2015/09/main">
+    <mc:Choice Requires="p159">
       <p:transition xmlns:p14="http://schemas.microsoft.com/office/powerpoint/2010/main" spd="slow" p14:dur="2000">
         <p159:morph option="byObject"/>
       </p:transition>
     </mc:Choice>
-    <mc:Fallback>
+    <mc:Fallback xmlns="">
+      <p:transition spd="slow">
+        <p:fade/>
+      </p:transition>
+    </mc:Fallback>
+  </mc:AlternateContent>
+</p:sld>
+</file>
+
+<file path=ppt/slides/slide13.xml><?xml version="1.0" encoding="utf-8"?>
+<p:sld xmlns:a="http://schemas.openxmlformats.org/drawingml/2006/main" xmlns:r="http://schemas.openxmlformats.org/officeDocument/2006/relationships" xmlns:p="http://schemas.openxmlformats.org/presentationml/2006/main">
+  <p:cSld>
+    <p:spTree>
+      <p:nvGrpSpPr>
+        <p:cNvPr id="1" name="Shape 143">
+          <a:extLst>
+            <a:ext uri="{FF2B5EF4-FFF2-40B4-BE49-F238E27FC236}">
+              <a16:creationId xmlns:a16="http://schemas.microsoft.com/office/drawing/2014/main" id="{C51078F4-0455-8844-38C2-A2341D7C8BFD}"/>
+            </a:ext>
+          </a:extLst>
+        </p:cNvPr>
+        <p:cNvGrpSpPr/>
+        <p:nvPr/>
+      </p:nvGrpSpPr>
+      <p:grpSpPr>
+        <a:xfrm>
+          <a:off x="0" y="0"/>
+          <a:ext cx="0" cy="0"/>
+          <a:chOff x="0" y="0"/>
+          <a:chExt cx="0" cy="0"/>
+        </a:xfrm>
+      </p:grpSpPr>
+      <p:sp>
+        <p:nvSpPr>
+          <p:cNvPr id="5" name="Rechteck 4">
+            <a:extLst>
+              <a:ext uri="{FF2B5EF4-FFF2-40B4-BE49-F238E27FC236}">
+                <a16:creationId xmlns:a16="http://schemas.microsoft.com/office/drawing/2014/main" id="{451991F8-23BF-50E6-6DA0-F4BF93E2A86E}"/>
+              </a:ext>
+            </a:extLst>
+          </p:cNvPr>
+          <p:cNvSpPr/>
+          <p:nvPr/>
+        </p:nvSpPr>
+        <p:spPr>
+          <a:xfrm>
+            <a:off x="4878065" y="823020"/>
+            <a:ext cx="12181306" cy="8628488"/>
+          </a:xfrm>
+          <a:prstGeom prst="rect">
+            <a:avLst/>
+          </a:prstGeom>
+          <a:noFill/>
+          <a:ln>
+            <a:solidFill>
+              <a:srgbClr val="FFC000"/>
+            </a:solidFill>
+          </a:ln>
+        </p:spPr>
+        <p:style>
+          <a:lnRef idx="2">
+            <a:schemeClr val="accent1">
+              <a:shade val="15000"/>
+            </a:schemeClr>
+          </a:lnRef>
+          <a:fillRef idx="1">
+            <a:schemeClr val="accent1"/>
+          </a:fillRef>
+          <a:effectRef idx="0">
+            <a:schemeClr val="accent1"/>
+          </a:effectRef>
+          <a:fontRef idx="minor">
+            <a:schemeClr val="lt1"/>
+          </a:fontRef>
+        </p:style>
+        <p:txBody>
+          <a:bodyPr rtlCol="0" anchor="ctr"/>
+          <a:lstStyle/>
+          <a:p>
+            <a:pPr algn="ctr"/>
+            <a:endParaRPr lang="de-DE"/>
+          </a:p>
+        </p:txBody>
+      </p:sp>
+      <p:sp>
+        <p:nvSpPr>
+          <p:cNvPr id="18" name="Oval 17">
+            <a:extLst>
+              <a:ext uri="{FF2B5EF4-FFF2-40B4-BE49-F238E27FC236}">
+                <a16:creationId xmlns:a16="http://schemas.microsoft.com/office/drawing/2014/main" id="{1FED2717-B14C-8925-BC98-E5EDB3D4B940}"/>
+              </a:ext>
+            </a:extLst>
+          </p:cNvPr>
+          <p:cNvSpPr/>
+          <p:nvPr/>
+        </p:nvSpPr>
+        <p:spPr>
+          <a:xfrm>
+            <a:off x="6455988" y="5017451"/>
+            <a:ext cx="914400" cy="914400"/>
+          </a:xfrm>
+          <a:prstGeom prst="ellipse">
+            <a:avLst/>
+          </a:prstGeom>
+          <a:solidFill>
+            <a:schemeClr val="tx1"/>
+          </a:solidFill>
+          <a:ln>
+            <a:solidFill>
+              <a:srgbClr val="FFC000"/>
+            </a:solidFill>
+          </a:ln>
+        </p:spPr>
+        <p:style>
+          <a:lnRef idx="2">
+            <a:schemeClr val="accent1">
+              <a:shade val="15000"/>
+            </a:schemeClr>
+          </a:lnRef>
+          <a:fillRef idx="1">
+            <a:schemeClr val="accent1"/>
+          </a:fillRef>
+          <a:effectRef idx="0">
+            <a:schemeClr val="accent1"/>
+          </a:effectRef>
+          <a:fontRef idx="minor">
+            <a:schemeClr val="lt1"/>
+          </a:fontRef>
+        </p:style>
+        <p:txBody>
+          <a:bodyPr rtlCol="0" anchor="ctr"/>
+          <a:lstStyle/>
+          <a:p>
+            <a:pPr algn="ctr"/>
+            <a:endParaRPr lang="de-DE"/>
+          </a:p>
+        </p:txBody>
+      </p:sp>
+      <p:sp>
+        <p:nvSpPr>
+          <p:cNvPr id="19" name="Oval 18">
+            <a:extLst>
+              <a:ext uri="{FF2B5EF4-FFF2-40B4-BE49-F238E27FC236}">
+                <a16:creationId xmlns:a16="http://schemas.microsoft.com/office/drawing/2014/main" id="{A1A1A19E-0F5A-7EFC-B37B-5D654D7AED9F}"/>
+              </a:ext>
+            </a:extLst>
+          </p:cNvPr>
+          <p:cNvSpPr/>
+          <p:nvPr/>
+        </p:nvSpPr>
+        <p:spPr>
+          <a:xfrm>
+            <a:off x="8093004" y="4999484"/>
+            <a:ext cx="914400" cy="914400"/>
+          </a:xfrm>
+          <a:prstGeom prst="ellipse">
+            <a:avLst/>
+          </a:prstGeom>
+          <a:solidFill>
+            <a:schemeClr val="tx1"/>
+          </a:solidFill>
+          <a:ln>
+            <a:solidFill>
+              <a:srgbClr val="FFC000"/>
+            </a:solidFill>
+          </a:ln>
+        </p:spPr>
+        <p:style>
+          <a:lnRef idx="2">
+            <a:schemeClr val="accent1">
+              <a:shade val="15000"/>
+            </a:schemeClr>
+          </a:lnRef>
+          <a:fillRef idx="1">
+            <a:schemeClr val="accent1"/>
+          </a:fillRef>
+          <a:effectRef idx="0">
+            <a:schemeClr val="accent1"/>
+          </a:effectRef>
+          <a:fontRef idx="minor">
+            <a:schemeClr val="lt1"/>
+          </a:fontRef>
+        </p:style>
+        <p:txBody>
+          <a:bodyPr rtlCol="0" anchor="ctr"/>
+          <a:lstStyle/>
+          <a:p>
+            <a:pPr algn="ctr"/>
+            <a:endParaRPr lang="de-DE"/>
+          </a:p>
+        </p:txBody>
+      </p:sp>
+      <p:sp>
+        <p:nvSpPr>
+          <p:cNvPr id="20" name="Oval 19">
+            <a:extLst>
+              <a:ext uri="{FF2B5EF4-FFF2-40B4-BE49-F238E27FC236}">
+                <a16:creationId xmlns:a16="http://schemas.microsoft.com/office/drawing/2014/main" id="{96C4873D-F15C-7B77-DA2E-F8D7331661B6}"/>
+              </a:ext>
+            </a:extLst>
+          </p:cNvPr>
+          <p:cNvSpPr/>
+          <p:nvPr/>
+        </p:nvSpPr>
+        <p:spPr>
+          <a:xfrm>
+            <a:off x="14643959" y="5031568"/>
+            <a:ext cx="914400" cy="914400"/>
+          </a:xfrm>
+          <a:prstGeom prst="ellipse">
+            <a:avLst/>
+          </a:prstGeom>
+          <a:solidFill>
+            <a:schemeClr val="tx1"/>
+          </a:solidFill>
+          <a:ln>
+            <a:solidFill>
+              <a:srgbClr val="FFC000"/>
+            </a:solidFill>
+          </a:ln>
+        </p:spPr>
+        <p:style>
+          <a:lnRef idx="2">
+            <a:schemeClr val="accent1">
+              <a:shade val="15000"/>
+            </a:schemeClr>
+          </a:lnRef>
+          <a:fillRef idx="1">
+            <a:schemeClr val="accent1"/>
+          </a:fillRef>
+          <a:effectRef idx="0">
+            <a:schemeClr val="accent1"/>
+          </a:effectRef>
+          <a:fontRef idx="minor">
+            <a:schemeClr val="lt1"/>
+          </a:fontRef>
+        </p:style>
+        <p:txBody>
+          <a:bodyPr rtlCol="0" anchor="ctr"/>
+          <a:lstStyle/>
+          <a:p>
+            <a:pPr algn="ctr"/>
+            <a:endParaRPr lang="de-DE"/>
+          </a:p>
+        </p:txBody>
+      </p:sp>
+      <p:sp>
+        <p:nvSpPr>
+          <p:cNvPr id="21" name="Oval 20">
+            <a:extLst>
+              <a:ext uri="{FF2B5EF4-FFF2-40B4-BE49-F238E27FC236}">
+                <a16:creationId xmlns:a16="http://schemas.microsoft.com/office/drawing/2014/main" id="{C2D8831E-4AD3-C325-6045-22693527239F}"/>
+              </a:ext>
+            </a:extLst>
+          </p:cNvPr>
+          <p:cNvSpPr/>
+          <p:nvPr/>
+        </p:nvSpPr>
+        <p:spPr>
+          <a:xfrm>
+            <a:off x="11370623" y="5031568"/>
+            <a:ext cx="914400" cy="914400"/>
+          </a:xfrm>
+          <a:prstGeom prst="ellipse">
+            <a:avLst/>
+          </a:prstGeom>
+          <a:solidFill>
+            <a:schemeClr val="tx1"/>
+          </a:solidFill>
+          <a:ln>
+            <a:solidFill>
+              <a:srgbClr val="FFC000"/>
+            </a:solidFill>
+          </a:ln>
+        </p:spPr>
+        <p:style>
+          <a:lnRef idx="2">
+            <a:schemeClr val="accent1">
+              <a:shade val="15000"/>
+            </a:schemeClr>
+          </a:lnRef>
+          <a:fillRef idx="1">
+            <a:schemeClr val="accent1"/>
+          </a:fillRef>
+          <a:effectRef idx="0">
+            <a:schemeClr val="accent1"/>
+          </a:effectRef>
+          <a:fontRef idx="minor">
+            <a:schemeClr val="lt1"/>
+          </a:fontRef>
+        </p:style>
+        <p:txBody>
+          <a:bodyPr rtlCol="0" anchor="ctr"/>
+          <a:lstStyle/>
+          <a:p>
+            <a:pPr algn="ctr"/>
+            <a:endParaRPr lang="de-DE"/>
+          </a:p>
+        </p:txBody>
+      </p:sp>
+      <p:sp>
+        <p:nvSpPr>
+          <p:cNvPr id="22" name="Oval 21">
+            <a:extLst>
+              <a:ext uri="{FF2B5EF4-FFF2-40B4-BE49-F238E27FC236}">
+                <a16:creationId xmlns:a16="http://schemas.microsoft.com/office/drawing/2014/main" id="{1D2FAFA7-6F7B-ECF7-11F4-0FC3FA2A3B37}"/>
+              </a:ext>
+            </a:extLst>
+          </p:cNvPr>
+          <p:cNvSpPr/>
+          <p:nvPr/>
+        </p:nvSpPr>
+        <p:spPr>
+          <a:xfrm>
+            <a:off x="13007639" y="5054857"/>
+            <a:ext cx="914400" cy="914400"/>
+          </a:xfrm>
+          <a:prstGeom prst="ellipse">
+            <a:avLst/>
+          </a:prstGeom>
+          <a:solidFill>
+            <a:schemeClr val="tx1"/>
+          </a:solidFill>
+          <a:ln>
+            <a:solidFill>
+              <a:srgbClr val="FFC000"/>
+            </a:solidFill>
+          </a:ln>
+        </p:spPr>
+        <p:style>
+          <a:lnRef idx="2">
+            <a:schemeClr val="accent1">
+              <a:shade val="15000"/>
+            </a:schemeClr>
+          </a:lnRef>
+          <a:fillRef idx="1">
+            <a:schemeClr val="accent1"/>
+          </a:fillRef>
+          <a:effectRef idx="0">
+            <a:schemeClr val="accent1"/>
+          </a:effectRef>
+          <a:fontRef idx="minor">
+            <a:schemeClr val="lt1"/>
+          </a:fontRef>
+        </p:style>
+        <p:txBody>
+          <a:bodyPr rtlCol="0" anchor="ctr"/>
+          <a:lstStyle/>
+          <a:p>
+            <a:pPr algn="ctr"/>
+            <a:endParaRPr lang="de-DE"/>
+          </a:p>
+        </p:txBody>
+      </p:sp>
+      <p:sp>
+        <p:nvSpPr>
+          <p:cNvPr id="24" name="Google Shape;147;p16">
+            <a:extLst>
+              <a:ext uri="{FF2B5EF4-FFF2-40B4-BE49-F238E27FC236}">
+                <a16:creationId xmlns:a16="http://schemas.microsoft.com/office/drawing/2014/main" id="{DC6D2C70-C2EE-DF70-95BC-9280B0893191}"/>
+              </a:ext>
+            </a:extLst>
+          </p:cNvPr>
+          <p:cNvSpPr txBox="1"/>
+          <p:nvPr/>
+        </p:nvSpPr>
+        <p:spPr>
+          <a:xfrm rot="5400000">
+            <a:off x="13542379" y="4575359"/>
+            <a:ext cx="8229600" cy="1259447"/>
+          </a:xfrm>
+          <a:prstGeom prst="rect">
+            <a:avLst/>
+          </a:prstGeom>
+          <a:noFill/>
+          <a:ln>
+            <a:noFill/>
+          </a:ln>
+        </p:spPr>
+        <p:txBody>
+          <a:bodyPr spcFirstLastPara="1" wrap="square" lIns="0" tIns="0" rIns="0" bIns="0" anchor="t" anchorCtr="0">
+            <a:spAutoFit/>
+          </a:bodyPr>
+          <a:lstStyle/>
+          <a:p>
+            <a:pPr marL="0" marR="0" lvl="0" indent="0" algn="ctr" rtl="0">
+              <a:lnSpc>
+                <a:spcPct val="124000"/>
+              </a:lnSpc>
+              <a:spcBef>
+                <a:spcPts val="0"/>
+              </a:spcBef>
+              <a:spcAft>
+                <a:spcPts val="0"/>
+              </a:spcAft>
+              <a:buNone/>
+            </a:pPr>
+            <a:r>
+              <a:rPr lang="en-US" sz="6600" b="1" dirty="0">
+                <a:solidFill>
+                  <a:srgbClr val="D4D4D4"/>
+                </a:solidFill>
+                <a:latin typeface="Oswald"/>
+                <a:sym typeface="Oswald"/>
+              </a:rPr>
+              <a:t>LCD Displays</a:t>
+            </a:r>
+            <a:endParaRPr sz="6600" dirty="0"/>
+          </a:p>
+        </p:txBody>
+      </p:sp>
+      <p:sp>
+        <p:nvSpPr>
+          <p:cNvPr id="146" name="!!T2S">
+            <a:extLst>
+              <a:ext uri="{FF2B5EF4-FFF2-40B4-BE49-F238E27FC236}">
+                <a16:creationId xmlns:a16="http://schemas.microsoft.com/office/drawing/2014/main" id="{D4F492A8-21D1-F662-62D0-8916B4FE5A6B}"/>
+              </a:ext>
+            </a:extLst>
+          </p:cNvPr>
+          <p:cNvSpPr/>
+          <p:nvPr/>
+        </p:nvSpPr>
+        <p:spPr>
+          <a:xfrm>
+            <a:off x="0" y="1142576"/>
+            <a:ext cx="5406190" cy="3606238"/>
+          </a:xfrm>
+          <a:custGeom>
+            <a:avLst/>
+            <a:gdLst/>
+            <a:ahLst/>
+            <a:cxnLst/>
+            <a:rect l="l" t="t" r="r" b="b"/>
+            <a:pathLst>
+              <a:path w="13810523" h="4792440" extrusionOk="0">
+                <a:moveTo>
+                  <a:pt x="0" y="0"/>
+                </a:moveTo>
+                <a:lnTo>
+                  <a:pt x="13810523" y="0"/>
+                </a:lnTo>
+                <a:lnTo>
+                  <a:pt x="13810523" y="4792440"/>
+                </a:lnTo>
+                <a:lnTo>
+                  <a:pt x="0" y="4792440"/>
+                </a:lnTo>
+                <a:lnTo>
+                  <a:pt x="0" y="0"/>
+                </a:lnTo>
+                <a:close/>
+              </a:path>
+            </a:pathLst>
+          </a:custGeom>
+          <a:blipFill rotWithShape="1">
+            <a:blip r:embed="rId3">
+              <a:alphaModFix/>
+            </a:blip>
+            <a:stretch>
+              <a:fillRect l="-137270"/>
+            </a:stretch>
+          </a:blipFill>
+          <a:ln>
+            <a:noFill/>
+          </a:ln>
+        </p:spPr>
+        <p:txBody>
+          <a:bodyPr/>
+          <a:lstStyle/>
+          <a:p>
+            <a:endParaRPr lang="de-DE"/>
+          </a:p>
+        </p:txBody>
+      </p:sp>
+      <p:sp>
+        <p:nvSpPr>
+          <p:cNvPr id="144" name="!!T3S">
+            <a:extLst>
+              <a:ext uri="{FF2B5EF4-FFF2-40B4-BE49-F238E27FC236}">
+                <a16:creationId xmlns:a16="http://schemas.microsoft.com/office/drawing/2014/main" id="{08941A4F-8AD0-793D-8854-42DF0AFD48BB}"/>
+              </a:ext>
+            </a:extLst>
+          </p:cNvPr>
+          <p:cNvSpPr/>
+          <p:nvPr/>
+        </p:nvSpPr>
+        <p:spPr>
+          <a:xfrm>
+            <a:off x="-1" y="2551212"/>
+            <a:ext cx="6506062" cy="5200492"/>
+          </a:xfrm>
+          <a:custGeom>
+            <a:avLst/>
+            <a:gdLst/>
+            <a:ahLst/>
+            <a:cxnLst/>
+            <a:rect l="l" t="t" r="r" b="b"/>
+            <a:pathLst>
+              <a:path w="13810523" h="4792440" extrusionOk="0">
+                <a:moveTo>
+                  <a:pt x="0" y="0"/>
+                </a:moveTo>
+                <a:lnTo>
+                  <a:pt x="13810523" y="0"/>
+                </a:lnTo>
+                <a:lnTo>
+                  <a:pt x="13810523" y="4792440"/>
+                </a:lnTo>
+                <a:lnTo>
+                  <a:pt x="0" y="4792440"/>
+                </a:lnTo>
+                <a:lnTo>
+                  <a:pt x="0" y="0"/>
+                </a:lnTo>
+                <a:close/>
+              </a:path>
+            </a:pathLst>
+          </a:custGeom>
+          <a:blipFill rotWithShape="1">
+            <a:blip r:embed="rId3">
+              <a:alphaModFix/>
+            </a:blip>
+            <a:stretch>
+              <a:fillRect l="-137270"/>
+            </a:stretch>
+          </a:blipFill>
+          <a:ln>
+            <a:noFill/>
+          </a:ln>
+        </p:spPr>
+        <p:txBody>
+          <a:bodyPr/>
+          <a:lstStyle/>
+          <a:p>
+            <a:endParaRPr lang="de-DE" dirty="0"/>
+          </a:p>
+        </p:txBody>
+      </p:sp>
+      <p:sp>
+        <p:nvSpPr>
+          <p:cNvPr id="2" name="!!T1S">
+            <a:extLst>
+              <a:ext uri="{FF2B5EF4-FFF2-40B4-BE49-F238E27FC236}">
+                <a16:creationId xmlns:a16="http://schemas.microsoft.com/office/drawing/2014/main" id="{6DE012AE-7998-3019-E156-2EFB6C52B131}"/>
+              </a:ext>
+            </a:extLst>
+          </p:cNvPr>
+          <p:cNvSpPr/>
+          <p:nvPr/>
+        </p:nvSpPr>
+        <p:spPr>
+          <a:xfrm>
+            <a:off x="0" y="128484"/>
+            <a:ext cx="3609474" cy="2470111"/>
+          </a:xfrm>
+          <a:custGeom>
+            <a:avLst/>
+            <a:gdLst/>
+            <a:ahLst/>
+            <a:cxnLst/>
+            <a:rect l="l" t="t" r="r" b="b"/>
+            <a:pathLst>
+              <a:path w="13810523" h="4792440" extrusionOk="0">
+                <a:moveTo>
+                  <a:pt x="0" y="0"/>
+                </a:moveTo>
+                <a:lnTo>
+                  <a:pt x="13810523" y="0"/>
+                </a:lnTo>
+                <a:lnTo>
+                  <a:pt x="13810523" y="4792440"/>
+                </a:lnTo>
+                <a:lnTo>
+                  <a:pt x="0" y="4792440"/>
+                </a:lnTo>
+                <a:lnTo>
+                  <a:pt x="0" y="0"/>
+                </a:lnTo>
+                <a:close/>
+              </a:path>
+            </a:pathLst>
+          </a:custGeom>
+          <a:blipFill rotWithShape="1">
+            <a:blip r:embed="rId3">
+              <a:alphaModFix/>
+            </a:blip>
+            <a:stretch>
+              <a:fillRect l="-137270"/>
+            </a:stretch>
+          </a:blipFill>
+          <a:ln>
+            <a:noFill/>
+          </a:ln>
+        </p:spPr>
+        <p:txBody>
+          <a:bodyPr/>
+          <a:lstStyle/>
+          <a:p>
+            <a:endParaRPr lang="de-DE"/>
+          </a:p>
+        </p:txBody>
+      </p:sp>
+      <p:sp>
+        <p:nvSpPr>
+          <p:cNvPr id="7" name="!!T4S">
+            <a:extLst>
+              <a:ext uri="{FF2B5EF4-FFF2-40B4-BE49-F238E27FC236}">
+                <a16:creationId xmlns:a16="http://schemas.microsoft.com/office/drawing/2014/main" id="{C83770C8-364F-03D4-2532-B5162D4F1B1C}"/>
+              </a:ext>
+            </a:extLst>
+          </p:cNvPr>
+          <p:cNvSpPr/>
+          <p:nvPr/>
+        </p:nvSpPr>
+        <p:spPr>
+          <a:xfrm>
+            <a:off x="31916" y="5422664"/>
+            <a:ext cx="5406190" cy="3606238"/>
+          </a:xfrm>
+          <a:custGeom>
+            <a:avLst/>
+            <a:gdLst/>
+            <a:ahLst/>
+            <a:cxnLst/>
+            <a:rect l="l" t="t" r="r" b="b"/>
+            <a:pathLst>
+              <a:path w="13810523" h="4792440" extrusionOk="0">
+                <a:moveTo>
+                  <a:pt x="0" y="0"/>
+                </a:moveTo>
+                <a:lnTo>
+                  <a:pt x="13810523" y="0"/>
+                </a:lnTo>
+                <a:lnTo>
+                  <a:pt x="13810523" y="4792440"/>
+                </a:lnTo>
+                <a:lnTo>
+                  <a:pt x="0" y="4792440"/>
+                </a:lnTo>
+                <a:lnTo>
+                  <a:pt x="0" y="0"/>
+                </a:lnTo>
+                <a:close/>
+              </a:path>
+            </a:pathLst>
+          </a:custGeom>
+          <a:blipFill rotWithShape="1">
+            <a:blip r:embed="rId3">
+              <a:alphaModFix/>
+            </a:blip>
+            <a:stretch>
+              <a:fillRect l="-137270"/>
+            </a:stretch>
+          </a:blipFill>
+          <a:ln>
+            <a:noFill/>
+          </a:ln>
+        </p:spPr>
+        <p:txBody>
+          <a:bodyPr/>
+          <a:lstStyle/>
+          <a:p>
+            <a:endParaRPr lang="de-DE"/>
+          </a:p>
+        </p:txBody>
+      </p:sp>
+      <p:sp>
+        <p:nvSpPr>
+          <p:cNvPr id="148" name="T3T">
+            <a:extLst>
+              <a:ext uri="{FF2B5EF4-FFF2-40B4-BE49-F238E27FC236}">
+                <a16:creationId xmlns:a16="http://schemas.microsoft.com/office/drawing/2014/main" id="{51967B74-7E30-BDF7-6839-AB99AC559181}"/>
+              </a:ext>
+            </a:extLst>
+          </p:cNvPr>
+          <p:cNvSpPr txBox="1"/>
+          <p:nvPr/>
+        </p:nvSpPr>
+        <p:spPr>
+          <a:xfrm>
+            <a:off x="1268591" y="4276936"/>
+            <a:ext cx="4069968" cy="1183081"/>
+          </a:xfrm>
+          <a:prstGeom prst="rect">
+            <a:avLst/>
+          </a:prstGeom>
+          <a:noFill/>
+          <a:ln>
+            <a:noFill/>
+          </a:ln>
+        </p:spPr>
+        <p:txBody>
+          <a:bodyPr spcFirstLastPara="1" wrap="square" lIns="0" tIns="0" rIns="0" bIns="0" anchor="t" anchorCtr="0">
+            <a:spAutoFit/>
+          </a:bodyPr>
+          <a:lstStyle/>
+          <a:p>
+            <a:pPr marL="0" marR="0" lvl="0" indent="0" algn="l" rtl="0">
+              <a:lnSpc>
+                <a:spcPct val="124000"/>
+              </a:lnSpc>
+              <a:spcBef>
+                <a:spcPts val="0"/>
+              </a:spcBef>
+              <a:spcAft>
+                <a:spcPts val="0"/>
+              </a:spcAft>
+              <a:buNone/>
+            </a:pPr>
+            <a:r>
+              <a:rPr lang="en-US" sz="6200" b="0" i="0" u="none" strike="noStrike" cap="none" dirty="0">
+                <a:solidFill>
+                  <a:schemeClr val="bg1"/>
+                </a:solidFill>
+                <a:latin typeface="Oswald"/>
+                <a:ea typeface="Oswald"/>
+                <a:cs typeface="Oswald"/>
+                <a:sym typeface="Oswald"/>
+              </a:rPr>
+              <a:t>LCD Display</a:t>
+            </a:r>
+            <a:endParaRPr dirty="0">
+              <a:solidFill>
+                <a:schemeClr val="bg1"/>
+              </a:solidFill>
+            </a:endParaRPr>
+          </a:p>
+        </p:txBody>
+      </p:sp>
+      <p:sp>
+        <p:nvSpPr>
+          <p:cNvPr id="152" name="T3N">
+            <a:extLst>
+              <a:ext uri="{FF2B5EF4-FFF2-40B4-BE49-F238E27FC236}">
+                <a16:creationId xmlns:a16="http://schemas.microsoft.com/office/drawing/2014/main" id="{4932831D-6605-0837-3473-4C7B95865552}"/>
+              </a:ext>
+            </a:extLst>
+          </p:cNvPr>
+          <p:cNvSpPr txBox="1"/>
+          <p:nvPr/>
+        </p:nvSpPr>
+        <p:spPr>
+          <a:xfrm>
+            <a:off x="173733" y="4284085"/>
+            <a:ext cx="1094858" cy="1183081"/>
+          </a:xfrm>
+          <a:prstGeom prst="rect">
+            <a:avLst/>
+          </a:prstGeom>
+          <a:noFill/>
+          <a:ln>
+            <a:noFill/>
+          </a:ln>
+        </p:spPr>
+        <p:txBody>
+          <a:bodyPr spcFirstLastPara="1" wrap="square" lIns="0" tIns="0" rIns="0" bIns="0" anchor="t" anchorCtr="0">
+            <a:spAutoFit/>
+          </a:bodyPr>
+          <a:lstStyle/>
+          <a:p>
+            <a:pPr marL="0" marR="0" lvl="0" indent="0" algn="l" rtl="0">
+              <a:lnSpc>
+                <a:spcPct val="124000"/>
+              </a:lnSpc>
+              <a:spcBef>
+                <a:spcPts val="0"/>
+              </a:spcBef>
+              <a:spcAft>
+                <a:spcPts val="0"/>
+              </a:spcAft>
+              <a:buNone/>
+            </a:pPr>
+            <a:r>
+              <a:rPr lang="en-US" sz="6200" b="0" i="0" u="none" strike="noStrike" cap="none" dirty="0">
+                <a:solidFill>
+                  <a:srgbClr val="FFC000"/>
+                </a:solidFill>
+                <a:latin typeface="Oswald"/>
+                <a:ea typeface="Oswald"/>
+                <a:cs typeface="Oswald"/>
+                <a:sym typeface="Oswald"/>
+              </a:rPr>
+              <a:t>04</a:t>
+            </a:r>
+            <a:endParaRPr dirty="0">
+              <a:solidFill>
+                <a:srgbClr val="FFC000"/>
+              </a:solidFill>
+            </a:endParaRPr>
+          </a:p>
+        </p:txBody>
+      </p:sp>
+      <p:sp>
+        <p:nvSpPr>
+          <p:cNvPr id="25" name="Oval 24">
+            <a:extLst>
+              <a:ext uri="{FF2B5EF4-FFF2-40B4-BE49-F238E27FC236}">
+                <a16:creationId xmlns:a16="http://schemas.microsoft.com/office/drawing/2014/main" id="{412C62D3-9EDF-61CC-307E-D8BF7D5EC864}"/>
+              </a:ext>
+            </a:extLst>
+          </p:cNvPr>
+          <p:cNvSpPr/>
+          <p:nvPr/>
+        </p:nvSpPr>
+        <p:spPr>
+          <a:xfrm>
+            <a:off x="5580706" y="7917898"/>
+            <a:ext cx="914400" cy="914400"/>
+          </a:xfrm>
+          <a:prstGeom prst="ellipse">
+            <a:avLst/>
+          </a:prstGeom>
+          <a:solidFill>
+            <a:schemeClr val="tx1"/>
+          </a:solidFill>
+          <a:ln>
+            <a:solidFill>
+              <a:srgbClr val="FFC000"/>
+            </a:solidFill>
+          </a:ln>
+        </p:spPr>
+        <p:style>
+          <a:lnRef idx="2">
+            <a:schemeClr val="accent1">
+              <a:shade val="15000"/>
+            </a:schemeClr>
+          </a:lnRef>
+          <a:fillRef idx="1">
+            <a:schemeClr val="accent1"/>
+          </a:fillRef>
+          <a:effectRef idx="0">
+            <a:schemeClr val="accent1"/>
+          </a:effectRef>
+          <a:fontRef idx="minor">
+            <a:schemeClr val="lt1"/>
+          </a:fontRef>
+        </p:style>
+        <p:txBody>
+          <a:bodyPr rtlCol="0" anchor="ctr"/>
+          <a:lstStyle/>
+          <a:p>
+            <a:pPr algn="ctr"/>
+            <a:endParaRPr lang="de-DE"/>
+          </a:p>
+        </p:txBody>
+      </p:sp>
+      <p:sp>
+        <p:nvSpPr>
+          <p:cNvPr id="26" name="Oval 25">
+            <a:extLst>
+              <a:ext uri="{FF2B5EF4-FFF2-40B4-BE49-F238E27FC236}">
+                <a16:creationId xmlns:a16="http://schemas.microsoft.com/office/drawing/2014/main" id="{02F38518-AB38-305E-B1A0-4566BCC8B289}"/>
+              </a:ext>
+            </a:extLst>
+          </p:cNvPr>
+          <p:cNvSpPr/>
+          <p:nvPr/>
+        </p:nvSpPr>
+        <p:spPr>
+          <a:xfrm>
+            <a:off x="7217722" y="7899931"/>
+            <a:ext cx="914400" cy="914400"/>
+          </a:xfrm>
+          <a:prstGeom prst="ellipse">
+            <a:avLst/>
+          </a:prstGeom>
+          <a:solidFill>
+            <a:schemeClr val="tx1"/>
+          </a:solidFill>
+          <a:ln>
+            <a:solidFill>
+              <a:srgbClr val="FFC000"/>
+            </a:solidFill>
+          </a:ln>
+        </p:spPr>
+        <p:style>
+          <a:lnRef idx="2">
+            <a:schemeClr val="accent1">
+              <a:shade val="15000"/>
+            </a:schemeClr>
+          </a:lnRef>
+          <a:fillRef idx="1">
+            <a:schemeClr val="accent1"/>
+          </a:fillRef>
+          <a:effectRef idx="0">
+            <a:schemeClr val="accent1"/>
+          </a:effectRef>
+          <a:fontRef idx="minor">
+            <a:schemeClr val="lt1"/>
+          </a:fontRef>
+        </p:style>
+        <p:txBody>
+          <a:bodyPr rtlCol="0" anchor="ctr"/>
+          <a:lstStyle/>
+          <a:p>
+            <a:pPr algn="ctr"/>
+            <a:endParaRPr lang="de-DE"/>
+          </a:p>
+        </p:txBody>
+      </p:sp>
+      <p:sp>
+        <p:nvSpPr>
+          <p:cNvPr id="27" name="Oval 26">
+            <a:extLst>
+              <a:ext uri="{FF2B5EF4-FFF2-40B4-BE49-F238E27FC236}">
+                <a16:creationId xmlns:a16="http://schemas.microsoft.com/office/drawing/2014/main" id="{5A5D66BA-CDBE-1E5E-D59D-63788D449739}"/>
+              </a:ext>
+            </a:extLst>
+          </p:cNvPr>
+          <p:cNvSpPr/>
+          <p:nvPr/>
+        </p:nvSpPr>
+        <p:spPr>
+          <a:xfrm>
+            <a:off x="8858325" y="7938301"/>
+            <a:ext cx="914400" cy="914400"/>
+          </a:xfrm>
+          <a:prstGeom prst="ellipse">
+            <a:avLst/>
+          </a:prstGeom>
+          <a:solidFill>
+            <a:schemeClr val="tx1"/>
+          </a:solidFill>
+          <a:ln>
+            <a:solidFill>
+              <a:srgbClr val="FFC000"/>
+            </a:solidFill>
+          </a:ln>
+        </p:spPr>
+        <p:style>
+          <a:lnRef idx="2">
+            <a:schemeClr val="accent1">
+              <a:shade val="15000"/>
+            </a:schemeClr>
+          </a:lnRef>
+          <a:fillRef idx="1">
+            <a:schemeClr val="accent1"/>
+          </a:fillRef>
+          <a:effectRef idx="0">
+            <a:schemeClr val="accent1"/>
+          </a:effectRef>
+          <a:fontRef idx="minor">
+            <a:schemeClr val="lt1"/>
+          </a:fontRef>
+        </p:style>
+        <p:txBody>
+          <a:bodyPr rtlCol="0" anchor="ctr"/>
+          <a:lstStyle/>
+          <a:p>
+            <a:pPr algn="ctr"/>
+            <a:endParaRPr lang="de-DE"/>
+          </a:p>
+        </p:txBody>
+      </p:sp>
+      <p:sp>
+        <p:nvSpPr>
+          <p:cNvPr id="28" name="Oval 27">
+            <a:extLst>
+              <a:ext uri="{FF2B5EF4-FFF2-40B4-BE49-F238E27FC236}">
+                <a16:creationId xmlns:a16="http://schemas.microsoft.com/office/drawing/2014/main" id="{CC710733-B6A5-F8F1-1842-4D5034D763F2}"/>
+              </a:ext>
+            </a:extLst>
+          </p:cNvPr>
+          <p:cNvSpPr/>
+          <p:nvPr/>
+        </p:nvSpPr>
+        <p:spPr>
+          <a:xfrm>
+            <a:off x="10495341" y="7932015"/>
+            <a:ext cx="914400" cy="914400"/>
+          </a:xfrm>
+          <a:prstGeom prst="ellipse">
+            <a:avLst/>
+          </a:prstGeom>
+          <a:solidFill>
+            <a:schemeClr val="tx1"/>
+          </a:solidFill>
+          <a:ln>
+            <a:solidFill>
+              <a:srgbClr val="FFC000"/>
+            </a:solidFill>
+          </a:ln>
+        </p:spPr>
+        <p:style>
+          <a:lnRef idx="2">
+            <a:schemeClr val="accent1">
+              <a:shade val="15000"/>
+            </a:schemeClr>
+          </a:lnRef>
+          <a:fillRef idx="1">
+            <a:schemeClr val="accent1"/>
+          </a:fillRef>
+          <a:effectRef idx="0">
+            <a:schemeClr val="accent1"/>
+          </a:effectRef>
+          <a:fontRef idx="minor">
+            <a:schemeClr val="lt1"/>
+          </a:fontRef>
+        </p:style>
+        <p:txBody>
+          <a:bodyPr rtlCol="0" anchor="ctr"/>
+          <a:lstStyle/>
+          <a:p>
+            <a:pPr algn="ctr"/>
+            <a:endParaRPr lang="de-DE"/>
+          </a:p>
+        </p:txBody>
+      </p:sp>
+      <p:sp>
+        <p:nvSpPr>
+          <p:cNvPr id="29" name="Oval 28">
+            <a:extLst>
+              <a:ext uri="{FF2B5EF4-FFF2-40B4-BE49-F238E27FC236}">
+                <a16:creationId xmlns:a16="http://schemas.microsoft.com/office/drawing/2014/main" id="{484C31C8-A3A2-8BC3-F4D9-A3FE201FEA10}"/>
+              </a:ext>
+            </a:extLst>
+          </p:cNvPr>
+          <p:cNvSpPr/>
+          <p:nvPr/>
+        </p:nvSpPr>
+        <p:spPr>
+          <a:xfrm>
+            <a:off x="12132357" y="7955304"/>
+            <a:ext cx="914400" cy="914400"/>
+          </a:xfrm>
+          <a:prstGeom prst="ellipse">
+            <a:avLst/>
+          </a:prstGeom>
+          <a:solidFill>
+            <a:schemeClr val="tx1"/>
+          </a:solidFill>
+          <a:ln>
+            <a:solidFill>
+              <a:srgbClr val="FFC000"/>
+            </a:solidFill>
+          </a:ln>
+        </p:spPr>
+        <p:style>
+          <a:lnRef idx="2">
+            <a:schemeClr val="accent1">
+              <a:shade val="15000"/>
+            </a:schemeClr>
+          </a:lnRef>
+          <a:fillRef idx="1">
+            <a:schemeClr val="accent1"/>
+          </a:fillRef>
+          <a:effectRef idx="0">
+            <a:schemeClr val="accent1"/>
+          </a:effectRef>
+          <a:fontRef idx="minor">
+            <a:schemeClr val="lt1"/>
+          </a:fontRef>
+        </p:style>
+        <p:txBody>
+          <a:bodyPr rtlCol="0" anchor="ctr"/>
+          <a:lstStyle/>
+          <a:p>
+            <a:pPr algn="ctr"/>
+            <a:endParaRPr lang="de-DE"/>
+          </a:p>
+        </p:txBody>
+      </p:sp>
+      <p:sp>
+        <p:nvSpPr>
+          <p:cNvPr id="30" name="Oval 29">
+            <a:extLst>
+              <a:ext uri="{FF2B5EF4-FFF2-40B4-BE49-F238E27FC236}">
+                <a16:creationId xmlns:a16="http://schemas.microsoft.com/office/drawing/2014/main" id="{FE7D0186-1C0F-B62D-F2C4-55DB1D5BC4E9}"/>
+              </a:ext>
+            </a:extLst>
+          </p:cNvPr>
+          <p:cNvSpPr/>
+          <p:nvPr/>
+        </p:nvSpPr>
+        <p:spPr>
+          <a:xfrm>
+            <a:off x="13769373" y="7904817"/>
+            <a:ext cx="914400" cy="914400"/>
+          </a:xfrm>
+          <a:prstGeom prst="ellipse">
+            <a:avLst/>
+          </a:prstGeom>
+          <a:solidFill>
+            <a:schemeClr val="tx1"/>
+          </a:solidFill>
+          <a:ln>
+            <a:solidFill>
+              <a:srgbClr val="FFC000"/>
+            </a:solidFill>
+          </a:ln>
+        </p:spPr>
+        <p:style>
+          <a:lnRef idx="2">
+            <a:schemeClr val="accent1">
+              <a:shade val="15000"/>
+            </a:schemeClr>
+          </a:lnRef>
+          <a:fillRef idx="1">
+            <a:schemeClr val="accent1"/>
+          </a:fillRef>
+          <a:effectRef idx="0">
+            <a:schemeClr val="accent1"/>
+          </a:effectRef>
+          <a:fontRef idx="minor">
+            <a:schemeClr val="lt1"/>
+          </a:fontRef>
+        </p:style>
+        <p:txBody>
+          <a:bodyPr rtlCol="0" anchor="ctr"/>
+          <a:lstStyle/>
+          <a:p>
+            <a:pPr algn="ctr"/>
+            <a:endParaRPr lang="de-DE"/>
+          </a:p>
+        </p:txBody>
+      </p:sp>
+      <p:sp>
+        <p:nvSpPr>
+          <p:cNvPr id="31" name="Oval 30">
+            <a:extLst>
+              <a:ext uri="{FF2B5EF4-FFF2-40B4-BE49-F238E27FC236}">
+                <a16:creationId xmlns:a16="http://schemas.microsoft.com/office/drawing/2014/main" id="{17EE36DE-2390-247F-80BA-6EA20913E073}"/>
+              </a:ext>
+            </a:extLst>
+          </p:cNvPr>
+          <p:cNvSpPr/>
+          <p:nvPr/>
+        </p:nvSpPr>
+        <p:spPr>
+          <a:xfrm>
+            <a:off x="15406389" y="7928106"/>
+            <a:ext cx="914400" cy="914400"/>
+          </a:xfrm>
+          <a:prstGeom prst="ellipse">
+            <a:avLst/>
+          </a:prstGeom>
+          <a:solidFill>
+            <a:schemeClr val="tx1"/>
+          </a:solidFill>
+          <a:ln>
+            <a:solidFill>
+              <a:srgbClr val="FFC000"/>
+            </a:solidFill>
+          </a:ln>
+        </p:spPr>
+        <p:style>
+          <a:lnRef idx="2">
+            <a:schemeClr val="accent1">
+              <a:shade val="15000"/>
+            </a:schemeClr>
+          </a:lnRef>
+          <a:fillRef idx="1">
+            <a:schemeClr val="accent1"/>
+          </a:fillRef>
+          <a:effectRef idx="0">
+            <a:schemeClr val="accent1"/>
+          </a:effectRef>
+          <a:fontRef idx="minor">
+            <a:schemeClr val="lt1"/>
+          </a:fontRef>
+        </p:style>
+        <p:txBody>
+          <a:bodyPr rtlCol="0" anchor="ctr"/>
+          <a:lstStyle/>
+          <a:p>
+            <a:pPr algn="ctr"/>
+            <a:endParaRPr lang="de-DE"/>
+          </a:p>
+        </p:txBody>
+      </p:sp>
+      <p:sp>
+        <p:nvSpPr>
+          <p:cNvPr id="32" name="Rechteck 31">
+            <a:extLst>
+              <a:ext uri="{FF2B5EF4-FFF2-40B4-BE49-F238E27FC236}">
+                <a16:creationId xmlns:a16="http://schemas.microsoft.com/office/drawing/2014/main" id="{062D070D-F2BE-0D39-7EAD-1E87B395F419}"/>
+              </a:ext>
+            </a:extLst>
+          </p:cNvPr>
+          <p:cNvSpPr/>
+          <p:nvPr/>
+        </p:nvSpPr>
+        <p:spPr>
+          <a:xfrm>
+            <a:off x="7718381" y="1417296"/>
+            <a:ext cx="6506062" cy="3006124"/>
+          </a:xfrm>
+          <a:prstGeom prst="rect">
+            <a:avLst/>
+          </a:prstGeom>
+          <a:ln>
+            <a:noFill/>
+          </a:ln>
+        </p:spPr>
+        <p:style>
+          <a:lnRef idx="2">
+            <a:schemeClr val="accent1">
+              <a:shade val="15000"/>
+            </a:schemeClr>
+          </a:lnRef>
+          <a:fillRef idx="1">
+            <a:schemeClr val="accent1"/>
+          </a:fillRef>
+          <a:effectRef idx="0">
+            <a:schemeClr val="accent1"/>
+          </a:effectRef>
+          <a:fontRef idx="minor">
+            <a:schemeClr val="lt1"/>
+          </a:fontRef>
+        </p:style>
+        <p:txBody>
+          <a:bodyPr rtlCol="0" anchor="ctr"/>
+          <a:lstStyle/>
+          <a:p>
+            <a:pPr algn="ctr"/>
+            <a:endParaRPr lang="de-DE"/>
+          </a:p>
+        </p:txBody>
+      </p:sp>
+      <p:sp>
+        <p:nvSpPr>
+          <p:cNvPr id="48" name="Textfeld 47">
+            <a:extLst>
+              <a:ext uri="{FF2B5EF4-FFF2-40B4-BE49-F238E27FC236}">
+                <a16:creationId xmlns:a16="http://schemas.microsoft.com/office/drawing/2014/main" id="{7D6A0A77-F876-01DA-ACD0-6ED1AF8A6DDB}"/>
+              </a:ext>
+            </a:extLst>
+          </p:cNvPr>
+          <p:cNvSpPr txBox="1"/>
+          <p:nvPr/>
+        </p:nvSpPr>
+        <p:spPr>
+          <a:xfrm>
+            <a:off x="370968" y="-8970068"/>
+            <a:ext cx="2876876" cy="892552"/>
+          </a:xfrm>
+          <a:prstGeom prst="rect">
+            <a:avLst/>
+          </a:prstGeom>
+          <a:solidFill>
+            <a:schemeClr val="tx1">
+              <a:lumMod val="65000"/>
+              <a:lumOff val="35000"/>
+            </a:schemeClr>
+          </a:solidFill>
+        </p:spPr>
+        <p:txBody>
+          <a:bodyPr wrap="square" rtlCol="0">
+            <a:spAutoFit/>
+          </a:bodyPr>
+          <a:lstStyle/>
+          <a:p>
+            <a:pPr algn="ctr"/>
+            <a:r>
+              <a:rPr lang="de-DE" sz="3200" b="1" dirty="0">
+                <a:solidFill>
+                  <a:srgbClr val="FFC000"/>
+                </a:solidFill>
+              </a:rPr>
+              <a:t>MIDI</a:t>
+            </a:r>
+            <a:br>
+              <a:rPr lang="de-DE" sz="3200" b="1" dirty="0">
+                <a:solidFill>
+                  <a:srgbClr val="FFC000"/>
+                </a:solidFill>
+              </a:rPr>
+            </a:br>
+            <a:r>
+              <a:rPr lang="de-DE" sz="2000" dirty="0">
+                <a:solidFill>
+                  <a:srgbClr val="FFC000"/>
+                </a:solidFill>
+              </a:rPr>
+              <a:t>IN - OUT - THRU</a:t>
+            </a:r>
+          </a:p>
+        </p:txBody>
+      </p:sp>
+      <p:sp>
+        <p:nvSpPr>
+          <p:cNvPr id="49" name="Textfeld 48">
+            <a:extLst>
+              <a:ext uri="{FF2B5EF4-FFF2-40B4-BE49-F238E27FC236}">
+                <a16:creationId xmlns:a16="http://schemas.microsoft.com/office/drawing/2014/main" id="{18127FB6-5082-CCBC-63BD-4B3D328C07FA}"/>
+              </a:ext>
+            </a:extLst>
+          </p:cNvPr>
+          <p:cNvSpPr txBox="1"/>
+          <p:nvPr/>
+        </p:nvSpPr>
+        <p:spPr>
+          <a:xfrm>
+            <a:off x="10824806" y="-12263210"/>
+            <a:ext cx="2891992" cy="892552"/>
+          </a:xfrm>
+          <a:prstGeom prst="rect">
+            <a:avLst/>
+          </a:prstGeom>
+          <a:solidFill>
+            <a:schemeClr val="tx1">
+              <a:lumMod val="65000"/>
+              <a:lumOff val="35000"/>
+            </a:schemeClr>
+          </a:solidFill>
+        </p:spPr>
+        <p:txBody>
+          <a:bodyPr wrap="square" rtlCol="0">
+            <a:spAutoFit/>
+          </a:bodyPr>
+          <a:lstStyle/>
+          <a:p>
+            <a:pPr algn="ctr"/>
+            <a:r>
+              <a:rPr lang="de-DE" sz="3200" b="1" dirty="0">
+                <a:solidFill>
+                  <a:srgbClr val="FFC000"/>
+                </a:solidFill>
+              </a:rPr>
+              <a:t>NETWORK</a:t>
+            </a:r>
+            <a:br>
+              <a:rPr lang="de-DE" sz="3200" b="1" dirty="0">
+                <a:solidFill>
+                  <a:srgbClr val="FFC000"/>
+                </a:solidFill>
+              </a:rPr>
+            </a:br>
+            <a:r>
+              <a:rPr lang="de-DE" sz="2000" dirty="0">
+                <a:solidFill>
+                  <a:srgbClr val="FFC000"/>
+                </a:solidFill>
+              </a:rPr>
+              <a:t>CAT5 / WLAN</a:t>
+            </a:r>
+          </a:p>
+        </p:txBody>
+      </p:sp>
+      <p:sp>
+        <p:nvSpPr>
+          <p:cNvPr id="50" name="Textfeld 49">
+            <a:extLst>
+              <a:ext uri="{FF2B5EF4-FFF2-40B4-BE49-F238E27FC236}">
+                <a16:creationId xmlns:a16="http://schemas.microsoft.com/office/drawing/2014/main" id="{12542F60-0FD3-9FDF-AE0F-5885380DE975}"/>
+              </a:ext>
+            </a:extLst>
+          </p:cNvPr>
+          <p:cNvSpPr txBox="1"/>
+          <p:nvPr/>
+        </p:nvSpPr>
+        <p:spPr>
+          <a:xfrm>
+            <a:off x="20449256" y="-15810828"/>
+            <a:ext cx="2908815" cy="892552"/>
+          </a:xfrm>
+          <a:prstGeom prst="rect">
+            <a:avLst/>
+          </a:prstGeom>
+          <a:solidFill>
+            <a:schemeClr val="tx1">
+              <a:lumMod val="65000"/>
+              <a:lumOff val="35000"/>
+            </a:schemeClr>
+          </a:solidFill>
+        </p:spPr>
+        <p:txBody>
+          <a:bodyPr wrap="square" rtlCol="0">
+            <a:spAutoFit/>
+          </a:bodyPr>
+          <a:lstStyle/>
+          <a:p>
+            <a:pPr algn="ctr"/>
+            <a:r>
+              <a:rPr lang="de-DE" sz="3200" b="1" dirty="0">
+                <a:solidFill>
+                  <a:srgbClr val="FFC000"/>
+                </a:solidFill>
+              </a:rPr>
+              <a:t>USB</a:t>
+            </a:r>
+            <a:br>
+              <a:rPr lang="de-DE" sz="3200" b="1" dirty="0">
+                <a:solidFill>
+                  <a:srgbClr val="FFC000"/>
+                </a:solidFill>
+              </a:rPr>
+            </a:br>
+            <a:r>
+              <a:rPr lang="de-DE" sz="2000" dirty="0">
+                <a:solidFill>
+                  <a:srgbClr val="FFC000"/>
+                </a:solidFill>
+              </a:rPr>
+              <a:t>2.0 / 3.0</a:t>
+            </a:r>
+          </a:p>
+        </p:txBody>
+      </p:sp>
+      <p:sp>
+        <p:nvSpPr>
+          <p:cNvPr id="6" name="Rechteck 5">
+            <a:extLst>
+              <a:ext uri="{FF2B5EF4-FFF2-40B4-BE49-F238E27FC236}">
+                <a16:creationId xmlns:a16="http://schemas.microsoft.com/office/drawing/2014/main" id="{DB534344-4EFF-DA54-2423-E3ED1CB03F85}"/>
+              </a:ext>
+            </a:extLst>
+          </p:cNvPr>
+          <p:cNvSpPr/>
+          <p:nvPr/>
+        </p:nvSpPr>
+        <p:spPr>
+          <a:xfrm>
+            <a:off x="5557530" y="6489949"/>
+            <a:ext cx="2160851" cy="836974"/>
+          </a:xfrm>
+          <a:prstGeom prst="rect">
+            <a:avLst/>
+          </a:prstGeom>
+          <a:ln>
+            <a:noFill/>
+          </a:ln>
+        </p:spPr>
+        <p:style>
+          <a:lnRef idx="2">
+            <a:schemeClr val="accent1">
+              <a:shade val="15000"/>
+            </a:schemeClr>
+          </a:lnRef>
+          <a:fillRef idx="1">
+            <a:schemeClr val="accent1"/>
+          </a:fillRef>
+          <a:effectRef idx="0">
+            <a:schemeClr val="accent1"/>
+          </a:effectRef>
+          <a:fontRef idx="minor">
+            <a:schemeClr val="lt1"/>
+          </a:fontRef>
+        </p:style>
+        <p:txBody>
+          <a:bodyPr rtlCol="0" anchor="ctr"/>
+          <a:lstStyle/>
+          <a:p>
+            <a:pPr algn="ctr"/>
+            <a:endParaRPr lang="de-DE"/>
+          </a:p>
+        </p:txBody>
+      </p:sp>
+      <p:sp>
+        <p:nvSpPr>
+          <p:cNvPr id="10" name="Rechteck 9">
+            <a:extLst>
+              <a:ext uri="{FF2B5EF4-FFF2-40B4-BE49-F238E27FC236}">
+                <a16:creationId xmlns:a16="http://schemas.microsoft.com/office/drawing/2014/main" id="{E92599B9-B361-6257-EC6B-2FF356BEF80D}"/>
+              </a:ext>
+            </a:extLst>
+          </p:cNvPr>
+          <p:cNvSpPr/>
+          <p:nvPr/>
+        </p:nvSpPr>
+        <p:spPr>
+          <a:xfrm>
+            <a:off x="8434144" y="6489948"/>
+            <a:ext cx="2160851" cy="836974"/>
+          </a:xfrm>
+          <a:prstGeom prst="rect">
+            <a:avLst/>
+          </a:prstGeom>
+          <a:ln>
+            <a:noFill/>
+          </a:ln>
+        </p:spPr>
+        <p:style>
+          <a:lnRef idx="2">
+            <a:schemeClr val="accent1">
+              <a:shade val="15000"/>
+            </a:schemeClr>
+          </a:lnRef>
+          <a:fillRef idx="1">
+            <a:schemeClr val="accent1"/>
+          </a:fillRef>
+          <a:effectRef idx="0">
+            <a:schemeClr val="accent1"/>
+          </a:effectRef>
+          <a:fontRef idx="minor">
+            <a:schemeClr val="lt1"/>
+          </a:fontRef>
+        </p:style>
+        <p:txBody>
+          <a:bodyPr rtlCol="0" anchor="ctr"/>
+          <a:lstStyle/>
+          <a:p>
+            <a:pPr algn="ctr"/>
+            <a:endParaRPr lang="de-DE"/>
+          </a:p>
+        </p:txBody>
+      </p:sp>
+      <p:sp>
+        <p:nvSpPr>
+          <p:cNvPr id="11" name="Rechteck 10">
+            <a:extLst>
+              <a:ext uri="{FF2B5EF4-FFF2-40B4-BE49-F238E27FC236}">
+                <a16:creationId xmlns:a16="http://schemas.microsoft.com/office/drawing/2014/main" id="{7A7F95FC-8639-4D43-B52C-DFC8C08A968A}"/>
+              </a:ext>
+            </a:extLst>
+          </p:cNvPr>
+          <p:cNvSpPr/>
+          <p:nvPr/>
+        </p:nvSpPr>
+        <p:spPr>
+          <a:xfrm>
+            <a:off x="11313901" y="6489948"/>
+            <a:ext cx="2160851" cy="857515"/>
+          </a:xfrm>
+          <a:prstGeom prst="rect">
+            <a:avLst/>
+          </a:prstGeom>
+          <a:ln>
+            <a:noFill/>
+          </a:ln>
+        </p:spPr>
+        <p:style>
+          <a:lnRef idx="2">
+            <a:schemeClr val="accent1">
+              <a:shade val="15000"/>
+            </a:schemeClr>
+          </a:lnRef>
+          <a:fillRef idx="1">
+            <a:schemeClr val="accent1"/>
+          </a:fillRef>
+          <a:effectRef idx="0">
+            <a:schemeClr val="accent1"/>
+          </a:effectRef>
+          <a:fontRef idx="minor">
+            <a:schemeClr val="lt1"/>
+          </a:fontRef>
+        </p:style>
+        <p:txBody>
+          <a:bodyPr rtlCol="0" anchor="ctr"/>
+          <a:lstStyle/>
+          <a:p>
+            <a:pPr algn="ctr"/>
+            <a:endParaRPr lang="de-DE"/>
+          </a:p>
+        </p:txBody>
+      </p:sp>
+      <p:sp>
+        <p:nvSpPr>
+          <p:cNvPr id="12" name="Rechteck 11">
+            <a:extLst>
+              <a:ext uri="{FF2B5EF4-FFF2-40B4-BE49-F238E27FC236}">
+                <a16:creationId xmlns:a16="http://schemas.microsoft.com/office/drawing/2014/main" id="{759767B0-CE59-2489-4B61-4CA5D2FBB77B}"/>
+              </a:ext>
+            </a:extLst>
+          </p:cNvPr>
+          <p:cNvSpPr/>
+          <p:nvPr/>
+        </p:nvSpPr>
+        <p:spPr>
+          <a:xfrm>
+            <a:off x="14190515" y="6489948"/>
+            <a:ext cx="2160851" cy="857515"/>
+          </a:xfrm>
+          <a:prstGeom prst="rect">
+            <a:avLst/>
+          </a:prstGeom>
+          <a:ln>
+            <a:noFill/>
+          </a:ln>
+        </p:spPr>
+        <p:style>
+          <a:lnRef idx="2">
+            <a:schemeClr val="accent1">
+              <a:shade val="15000"/>
+            </a:schemeClr>
+          </a:lnRef>
+          <a:fillRef idx="1">
+            <a:schemeClr val="accent1"/>
+          </a:fillRef>
+          <a:effectRef idx="0">
+            <a:schemeClr val="accent1"/>
+          </a:effectRef>
+          <a:fontRef idx="minor">
+            <a:schemeClr val="lt1"/>
+          </a:fontRef>
+        </p:style>
+        <p:txBody>
+          <a:bodyPr rtlCol="0" anchor="ctr"/>
+          <a:lstStyle/>
+          <a:p>
+            <a:pPr algn="ctr"/>
+            <a:endParaRPr lang="de-DE"/>
+          </a:p>
+        </p:txBody>
+      </p:sp>
+    </p:spTree>
+    <p:extLst>
+      <p:ext uri="{BB962C8B-B14F-4D97-AF65-F5344CB8AC3E}">
+        <p14:creationId xmlns:p14="http://schemas.microsoft.com/office/powerpoint/2010/main" val="4176663068"/>
+      </p:ext>
+    </p:extLst>
+  </p:cSld>
+  <p:clrMapOvr>
+    <a:masterClrMapping/>
+  </p:clrMapOvr>
+  <mc:AlternateContent xmlns:mc="http://schemas.openxmlformats.org/markup-compatibility/2006" xmlns:p159="http://schemas.microsoft.com/office/powerpoint/2015/09/main">
+    <mc:Choice Requires="p159">
+      <p:transition xmlns:p14="http://schemas.microsoft.com/office/powerpoint/2010/main" spd="slow" p14:dur="2000">
+        <p159:morph option="byObject"/>
+      </p:transition>
+    </mc:Choice>
+    <mc:Fallback xmlns="">
       <p:transition spd="slow">
         <p:fade/>
       </p:transition>
@@ -21883,13 +23623,13 @@
   <p:clrMapOvr>
     <a:masterClrMapping/>
   </p:clrMapOvr>
-  <mc:AlternateContent xmlns:mc="http://schemas.openxmlformats.org/markup-compatibility/2006">
-    <mc:Choice xmlns:p159="http://schemas.microsoft.com/office/powerpoint/2015/09/main" Requires="p159">
+  <mc:AlternateContent xmlns:mc="http://schemas.openxmlformats.org/markup-compatibility/2006" xmlns:p159="http://schemas.microsoft.com/office/powerpoint/2015/09/main">
+    <mc:Choice Requires="p159">
       <p:transition xmlns:p14="http://schemas.microsoft.com/office/powerpoint/2010/main" spd="slow" p14:dur="2000">
         <p159:morph option="byObject"/>
       </p:transition>
     </mc:Choice>
-    <mc:Fallback>
+    <mc:Fallback xmlns="">
       <p:transition spd="slow">
         <p:fade/>
       </p:transition>
@@ -23509,13 +25249,13 @@
   <p:clrMapOvr>
     <a:masterClrMapping/>
   </p:clrMapOvr>
-  <mc:AlternateContent xmlns:mc="http://schemas.openxmlformats.org/markup-compatibility/2006">
-    <mc:Choice xmlns:p159="http://schemas.microsoft.com/office/powerpoint/2015/09/main" Requires="p159">
+  <mc:AlternateContent xmlns:mc="http://schemas.openxmlformats.org/markup-compatibility/2006" xmlns:p159="http://schemas.microsoft.com/office/powerpoint/2015/09/main">
+    <mc:Choice Requires="p159">
       <p:transition xmlns:p14="http://schemas.microsoft.com/office/powerpoint/2010/main" spd="slow" p14:dur="2000">
         <p159:morph option="byObject"/>
       </p:transition>
     </mc:Choice>
-    <mc:Fallback>
+    <mc:Fallback xmlns="">
       <p:transition spd="slow">
         <p:fade/>
       </p:transition>
@@ -25306,13 +27046,13 @@
   <p:clrMapOvr>
     <a:masterClrMapping/>
   </p:clrMapOvr>
-  <mc:AlternateContent xmlns:mc="http://schemas.openxmlformats.org/markup-compatibility/2006">
-    <mc:Choice xmlns:p159="http://schemas.microsoft.com/office/powerpoint/2015/09/main" Requires="p159">
+  <mc:AlternateContent xmlns:mc="http://schemas.openxmlformats.org/markup-compatibility/2006" xmlns:p159="http://schemas.microsoft.com/office/powerpoint/2015/09/main">
+    <mc:Choice Requires="p159">
       <p:transition xmlns:p14="http://schemas.microsoft.com/office/powerpoint/2010/main" spd="slow" p14:dur="2000">
         <p159:morph option="byObject"/>
       </p:transition>
     </mc:Choice>
-    <mc:Fallback>
+    <mc:Fallback xmlns="">
       <p:transition spd="slow">
         <p:fade/>
       </p:transition>
@@ -26008,13 +27748,13 @@
   <p:clrMapOvr>
     <a:masterClrMapping/>
   </p:clrMapOvr>
-  <mc:AlternateContent xmlns:mc="http://schemas.openxmlformats.org/markup-compatibility/2006">
-    <mc:Choice xmlns:p159="http://schemas.microsoft.com/office/powerpoint/2015/09/main" Requires="p159">
+  <mc:AlternateContent xmlns:mc="http://schemas.openxmlformats.org/markup-compatibility/2006" xmlns:p159="http://schemas.microsoft.com/office/powerpoint/2015/09/main">
+    <mc:Choice Requires="p159">
       <p:transition xmlns:p14="http://schemas.microsoft.com/office/powerpoint/2010/main" spd="slow" p14:dur="2000">
         <p159:morph option="byObject"/>
       </p:transition>
     </mc:Choice>
-    <mc:Fallback>
+    <mc:Fallback xmlns="">
       <p:transition spd="slow">
         <p:fade/>
       </p:transition>
@@ -28214,13 +29954,13 @@
   <p:clrMapOvr>
     <a:masterClrMapping/>
   </p:clrMapOvr>
-  <mc:AlternateContent xmlns:mc="http://schemas.openxmlformats.org/markup-compatibility/2006">
-    <mc:Choice xmlns:p159="http://schemas.microsoft.com/office/powerpoint/2015/09/main" Requires="p159">
+  <mc:AlternateContent xmlns:mc="http://schemas.openxmlformats.org/markup-compatibility/2006" xmlns:p159="http://schemas.microsoft.com/office/powerpoint/2015/09/main">
+    <mc:Choice Requires="p159">
       <p:transition xmlns:p14="http://schemas.microsoft.com/office/powerpoint/2010/main" spd="slow" p14:dur="2000">
         <p159:morph option="byObject"/>
       </p:transition>
     </mc:Choice>
-    <mc:Fallback>
+    <mc:Fallback xmlns="">
       <p:transition spd="slow">
         <p:fade/>
       </p:transition>
@@ -30433,13 +32173,13 @@
   <p:clrMapOvr>
     <a:masterClrMapping/>
   </p:clrMapOvr>
-  <mc:AlternateContent xmlns:mc="http://schemas.openxmlformats.org/markup-compatibility/2006">
-    <mc:Choice xmlns:p159="http://schemas.microsoft.com/office/powerpoint/2015/09/main" Requires="p159">
+  <mc:AlternateContent xmlns:mc="http://schemas.openxmlformats.org/markup-compatibility/2006" xmlns:p159="http://schemas.microsoft.com/office/powerpoint/2015/09/main">
+    <mc:Choice Requires="p159">
       <p:transition xmlns:p14="http://schemas.microsoft.com/office/powerpoint/2010/main" spd="slow" p14:dur="2000">
         <p159:morph option="byObject"/>
       </p:transition>
     </mc:Choice>
-    <mc:Fallback>
+    <mc:Fallback xmlns="">
       <p:transition spd="slow">
         <p:fade/>
       </p:transition>
@@ -32695,13 +34435,13 @@
   <p:clrMapOvr>
     <a:masterClrMapping/>
   </p:clrMapOvr>
-  <mc:AlternateContent xmlns:mc="http://schemas.openxmlformats.org/markup-compatibility/2006">
-    <mc:Choice xmlns:p159="http://schemas.microsoft.com/office/powerpoint/2015/09/main" Requires="p159">
+  <mc:AlternateContent xmlns:mc="http://schemas.openxmlformats.org/markup-compatibility/2006" xmlns:p159="http://schemas.microsoft.com/office/powerpoint/2015/09/main">
+    <mc:Choice Requires="p159">
       <p:transition xmlns:p14="http://schemas.microsoft.com/office/powerpoint/2010/main" spd="slow" p14:dur="2000">
         <p159:morph option="byObject"/>
       </p:transition>
     </mc:Choice>
-    <mc:Fallback>
+    <mc:Fallback xmlns="">
       <p:transition spd="slow">
         <p:fade/>
       </p:transition>
@@ -34951,13 +36691,13 @@
   <p:clrMapOvr>
     <a:masterClrMapping/>
   </p:clrMapOvr>
-  <mc:AlternateContent xmlns:mc="http://schemas.openxmlformats.org/markup-compatibility/2006">
-    <mc:Choice xmlns:p159="http://schemas.microsoft.com/office/powerpoint/2015/09/main" Requires="p159">
+  <mc:AlternateContent xmlns:mc="http://schemas.openxmlformats.org/markup-compatibility/2006" xmlns:p159="http://schemas.microsoft.com/office/powerpoint/2015/09/main">
+    <mc:Choice Requires="p159">
       <p:transition xmlns:p14="http://schemas.microsoft.com/office/powerpoint/2010/main" spd="slow" p14:dur="2000">
         <p159:morph option="byObject"/>
       </p:transition>
     </mc:Choice>
-    <mc:Fallback>
+    <mc:Fallback xmlns="">
       <p:transition spd="slow">
         <p:fade/>
       </p:transition>

</xml_diff>

<commit_message>
Me, Tools JavaFX LCD Simulator, LCD Fonts HUGO Bug fixes
</commit_message>
<xml_diff>
--- a/documentation/DIY-Pedalboard_01-11.pptx
+++ b/documentation/DIY-Pedalboard_01-11.pptx
@@ -2671,7 +2671,7 @@
             </a:pathLst>
           </a:custGeom>
           <a:blipFill rotWithShape="1">
-            <a:blip r:embed="rId2">
+            <a:blip>
               <a:alphaModFix/>
             </a:blip>
             <a:stretch>
@@ -2722,7 +2722,7 @@
             </a:pathLst>
           </a:custGeom>
           <a:blipFill rotWithShape="1">
-            <a:blip r:embed="rId3">
+            <a:blip>
               <a:alphaModFix/>
             </a:blip>
             <a:stretch>
@@ -3183,7 +3183,7 @@
           <p:nvPr/>
         </p:nvPicPr>
         <p:blipFill rotWithShape="1">
-          <a:blip r:embed="rId2">
+          <a:blip>
             <a:alphaModFix/>
           </a:blip>
           <a:srcRect l="15994" t="50553"/>
@@ -3654,7 +3654,7 @@
             </a:pathLst>
           </a:custGeom>
           <a:blipFill rotWithShape="1">
-            <a:blip r:embed="rId2">
+            <a:blip>
               <a:alphaModFix/>
             </a:blip>
             <a:stretch>
@@ -4876,7 +4876,7 @@
           <p:nvPr/>
         </p:nvPicPr>
         <p:blipFill rotWithShape="1">
-          <a:blip r:embed="rId2">
+          <a:blip>
             <a:alphaModFix/>
           </a:blip>
           <a:srcRect l="28143" t="15739" r="33917"/>
@@ -5450,7 +5450,7 @@
             </a:pathLst>
           </a:custGeom>
           <a:blipFill rotWithShape="1">
-            <a:blip r:embed="rId2">
+            <a:blip>
               <a:alphaModFix/>
             </a:blip>
             <a:stretch>
@@ -5501,7 +5501,7 @@
             </a:pathLst>
           </a:custGeom>
           <a:blipFill rotWithShape="1">
-            <a:blip r:embed="rId3">
+            <a:blip>
               <a:alphaModFix/>
             </a:blip>
             <a:stretch>
@@ -5552,7 +5552,7 @@
             </a:pathLst>
           </a:custGeom>
           <a:blipFill rotWithShape="1">
-            <a:blip r:embed="rId3">
+            <a:blip>
               <a:alphaModFix/>
             </a:blip>
             <a:stretch>
@@ -6022,7 +6022,7 @@
             </a:pathLst>
           </a:custGeom>
           <a:blipFill rotWithShape="1">
-            <a:blip r:embed="rId2">
+            <a:blip>
               <a:alphaModFix/>
             </a:blip>
             <a:stretch>
@@ -6073,7 +6073,7 @@
             </a:pathLst>
           </a:custGeom>
           <a:blipFill rotWithShape="1">
-            <a:blip r:embed="rId2">
+            <a:blip>
               <a:alphaModFix/>
             </a:blip>
             <a:stretch>
@@ -6124,7 +6124,7 @@
             </a:pathLst>
           </a:custGeom>
           <a:blipFill rotWithShape="1">
-            <a:blip r:embed="rId2">
+            <a:blip>
               <a:alphaModFix/>
             </a:blip>
             <a:stretch>
@@ -7012,7 +7012,7 @@
           <p:nvPr/>
         </p:nvPicPr>
         <p:blipFill rotWithShape="1">
-          <a:blip r:embed="rId2">
+          <a:blip>
             <a:alphaModFix/>
           </a:blip>
           <a:srcRect l="25138"/>
@@ -7039,7 +7039,7 @@
           <p:nvPr/>
         </p:nvPicPr>
         <p:blipFill rotWithShape="1">
-          <a:blip r:embed="rId2">
+          <a:blip>
             <a:alphaModFix/>
           </a:blip>
           <a:srcRect r="56368"/>
@@ -7523,7 +7523,7 @@
           <p:nvPr/>
         </p:nvPicPr>
         <p:blipFill rotWithShape="1">
-          <a:blip r:embed="rId2">
+          <a:blip>
             <a:alphaModFix/>
           </a:blip>
           <a:srcRect r="27536" b="27267"/>
@@ -7550,7 +7550,7 @@
           <p:nvPr/>
         </p:nvPicPr>
         <p:blipFill rotWithShape="1">
-          <a:blip r:embed="rId2">
+          <a:blip>
             <a:alphaModFix/>
           </a:blip>
           <a:srcRect l="32953" t="20166"/>
@@ -8270,7 +8270,7 @@
             </a:pathLst>
           </a:custGeom>
           <a:blipFill rotWithShape="1">
-            <a:blip r:embed="rId2">
+            <a:blip>
               <a:alphaModFix/>
             </a:blip>
             <a:stretch>
@@ -8687,7 +8687,7 @@
           <p:nvPr/>
         </p:nvPicPr>
         <p:blipFill rotWithShape="1">
-          <a:blip r:embed="rId2">
+          <a:blip>
             <a:alphaModFix/>
           </a:blip>
           <a:srcRect l="68166" b="69515"/>
@@ -8714,7 +8714,7 @@
           <p:nvPr/>
         </p:nvPicPr>
         <p:blipFill rotWithShape="1">
-          <a:blip r:embed="rId3">
+          <a:blip>
             <a:alphaModFix/>
           </a:blip>
           <a:srcRect r="35224" b="30986"/>
@@ -9653,7 +9653,7 @@
             </a:pathLst>
           </a:custGeom>
           <a:blipFill rotWithShape="1">
-            <a:blip r:embed="rId2">
+            <a:blip>
               <a:alphaModFix/>
             </a:blip>
             <a:stretch>
@@ -9704,7 +9704,7 @@
             </a:pathLst>
           </a:custGeom>
           <a:blipFill rotWithShape="1">
-            <a:blip r:embed="rId2">
+            <a:blip>
               <a:alphaModFix/>
             </a:blip>
             <a:stretch>
@@ -9755,7 +9755,7 @@
             </a:pathLst>
           </a:custGeom>
           <a:blipFill rotWithShape="1">
-            <a:blip r:embed="rId2">
+            <a:blip>
               <a:alphaModFix/>
             </a:blip>
             <a:stretch>
@@ -9806,7 +9806,7 @@
             </a:pathLst>
           </a:custGeom>
           <a:blipFill rotWithShape="1">
-            <a:blip r:embed="rId2">
+            <a:blip>
               <a:alphaModFix/>
             </a:blip>
             <a:stretch>
@@ -9857,7 +9857,7 @@
             </a:pathLst>
           </a:custGeom>
           <a:blipFill rotWithShape="1">
-            <a:blip r:embed="rId2">
+            <a:blip>
               <a:alphaModFix/>
             </a:blip>
             <a:stretch>
@@ -12433,7 +12433,7 @@
           <p:nvPr/>
         </p:nvPicPr>
         <p:blipFill rotWithShape="1">
-          <a:blip r:embed="rId2">
+          <a:blip>
             <a:alphaModFix/>
           </a:blip>
           <a:srcRect l="7052" t="19676" r="12626" b="1520"/>
@@ -12652,7 +12652,7 @@
             </a:pathLst>
           </a:custGeom>
           <a:blipFill rotWithShape="1">
-            <a:blip r:embed="rId3">
+            <a:blip>
               <a:alphaModFix/>
             </a:blip>
             <a:stretch>
@@ -12703,7 +12703,7 @@
             </a:pathLst>
           </a:custGeom>
           <a:blipFill rotWithShape="1">
-            <a:blip r:embed="rId3">
+            <a:blip>
               <a:alphaModFix/>
             </a:blip>
             <a:stretch>
@@ -14727,7 +14727,7 @@
             </a:pathLst>
           </a:custGeom>
           <a:blipFill rotWithShape="1">
-            <a:blip r:embed="rId3">
+            <a:blip>
               <a:alphaModFix/>
             </a:blip>
             <a:stretch>
@@ -14785,7 +14785,7 @@
             </a:pathLst>
           </a:custGeom>
           <a:blipFill rotWithShape="1">
-            <a:blip r:embed="rId4">
+            <a:blip>
               <a:alphaModFix/>
             </a:blip>
             <a:stretch>
@@ -14843,7 +14843,7 @@
             </a:pathLst>
           </a:custGeom>
           <a:blipFill rotWithShape="1">
-            <a:blip r:embed="rId4">
+            <a:blip>
               <a:alphaModFix/>
             </a:blip>
             <a:stretch>
@@ -16163,7 +16163,7 @@
             </a:pathLst>
           </a:custGeom>
           <a:blipFill rotWithShape="1">
-            <a:blip r:embed="rId3">
+            <a:blip>
               <a:alphaModFix/>
             </a:blip>
             <a:stretch>
@@ -16227,7 +16227,7 @@
             </a:pathLst>
           </a:custGeom>
           <a:blipFill rotWithShape="1">
-            <a:blip r:embed="rId3">
+            <a:blip>
               <a:alphaModFix/>
             </a:blip>
             <a:stretch>
@@ -16291,7 +16291,7 @@
             </a:pathLst>
           </a:custGeom>
           <a:blipFill rotWithShape="1">
-            <a:blip r:embed="rId3">
+            <a:blip>
               <a:alphaModFix/>
             </a:blip>
             <a:stretch>
@@ -16481,7 +16481,7 @@
             </a:pathLst>
           </a:custGeom>
           <a:blipFill rotWithShape="1">
-            <a:blip r:embed="rId3">
+            <a:blip>
               <a:alphaModFix/>
             </a:blip>
             <a:stretch>
@@ -16675,7 +16675,7 @@
             </a:pathLst>
           </a:custGeom>
           <a:blipFill rotWithShape="1">
-            <a:blip r:embed="rId3">
+            <a:blip>
               <a:alphaModFix/>
             </a:blip>
             <a:stretch>
@@ -18352,7 +18352,7 @@
             </a:pathLst>
           </a:custGeom>
           <a:blipFill rotWithShape="1">
-            <a:blip r:embed="rId3">
+            <a:blip>
               <a:alphaModFix/>
             </a:blip>
             <a:stretch>
@@ -18416,7 +18416,7 @@
             </a:pathLst>
           </a:custGeom>
           <a:blipFill rotWithShape="1">
-            <a:blip r:embed="rId3">
+            <a:blip>
               <a:alphaModFix/>
             </a:blip>
             <a:stretch>
@@ -18480,7 +18480,7 @@
             </a:pathLst>
           </a:custGeom>
           <a:blipFill rotWithShape="1">
-            <a:blip r:embed="rId3">
+            <a:blip>
               <a:alphaModFix/>
             </a:blip>
             <a:stretch>
@@ -18670,7 +18670,7 @@
             </a:pathLst>
           </a:custGeom>
           <a:blipFill rotWithShape="1">
-            <a:blip r:embed="rId3">
+            <a:blip>
               <a:alphaModFix/>
             </a:blip>
             <a:stretch>
@@ -18862,7 +18862,7 @@
             </a:pathLst>
           </a:custGeom>
           <a:blipFill rotWithShape="1">
-            <a:blip r:embed="rId3">
+            <a:blip>
               <a:alphaModFix/>
             </a:blip>
             <a:stretch>
@@ -20389,7 +20389,7 @@
             </a:pathLst>
           </a:custGeom>
           <a:blipFill rotWithShape="1">
-            <a:blip r:embed="rId3">
+            <a:blip>
               <a:alphaModFix/>
             </a:blip>
             <a:stretch>
@@ -20453,7 +20453,7 @@
             </a:pathLst>
           </a:custGeom>
           <a:blipFill rotWithShape="1">
-            <a:blip r:embed="rId3">
+            <a:blip>
               <a:alphaModFix/>
             </a:blip>
             <a:stretch>
@@ -20517,7 +20517,7 @@
             </a:pathLst>
           </a:custGeom>
           <a:blipFill rotWithShape="1">
-            <a:blip r:embed="rId3">
+            <a:blip>
               <a:alphaModFix/>
             </a:blip>
             <a:stretch>
@@ -20707,7 +20707,7 @@
             </a:pathLst>
           </a:custGeom>
           <a:blipFill rotWithShape="1">
-            <a:blip r:embed="rId3">
+            <a:blip>
               <a:alphaModFix/>
             </a:blip>
             <a:stretch>
@@ -20771,7 +20771,7 @@
             </a:pathLst>
           </a:custGeom>
           <a:blipFill rotWithShape="1">
-            <a:blip r:embed="rId3">
+            <a:blip>
               <a:alphaModFix/>
             </a:blip>
             <a:stretch>
@@ -21072,114 +21072,6 @@
       </p:sp>
       <p:sp>
         <p:nvSpPr>
-          <p:cNvPr id="18" name="Oval 17">
-            <a:extLst>
-              <a:ext uri="{FF2B5EF4-FFF2-40B4-BE49-F238E27FC236}">
-                <a16:creationId xmlns:a16="http://schemas.microsoft.com/office/drawing/2014/main" id="{1FED2717-B14C-8925-BC98-E5EDB3D4B940}"/>
-              </a:ext>
-            </a:extLst>
-          </p:cNvPr>
-          <p:cNvSpPr/>
-          <p:nvPr/>
-        </p:nvSpPr>
-        <p:spPr>
-          <a:xfrm>
-            <a:off x="6455988" y="5017451"/>
-            <a:ext cx="914400" cy="914400"/>
-          </a:xfrm>
-          <a:prstGeom prst="ellipse">
-            <a:avLst/>
-          </a:prstGeom>
-          <a:solidFill>
-            <a:schemeClr val="tx1"/>
-          </a:solidFill>
-          <a:ln>
-            <a:solidFill>
-              <a:srgbClr val="FFC000"/>
-            </a:solidFill>
-          </a:ln>
-        </p:spPr>
-        <p:style>
-          <a:lnRef idx="2">
-            <a:schemeClr val="accent1">
-              <a:shade val="15000"/>
-            </a:schemeClr>
-          </a:lnRef>
-          <a:fillRef idx="1">
-            <a:schemeClr val="accent1"/>
-          </a:fillRef>
-          <a:effectRef idx="0">
-            <a:schemeClr val="accent1"/>
-          </a:effectRef>
-          <a:fontRef idx="minor">
-            <a:schemeClr val="lt1"/>
-          </a:fontRef>
-        </p:style>
-        <p:txBody>
-          <a:bodyPr rtlCol="0" anchor="ctr"/>
-          <a:lstStyle/>
-          <a:p>
-            <a:pPr algn="ctr"/>
-            <a:endParaRPr lang="de-DE"/>
-          </a:p>
-        </p:txBody>
-      </p:sp>
-      <p:sp>
-        <p:nvSpPr>
-          <p:cNvPr id="19" name="Oval 18">
-            <a:extLst>
-              <a:ext uri="{FF2B5EF4-FFF2-40B4-BE49-F238E27FC236}">
-                <a16:creationId xmlns:a16="http://schemas.microsoft.com/office/drawing/2014/main" id="{A1A1A19E-0F5A-7EFC-B37B-5D654D7AED9F}"/>
-              </a:ext>
-            </a:extLst>
-          </p:cNvPr>
-          <p:cNvSpPr/>
-          <p:nvPr/>
-        </p:nvSpPr>
-        <p:spPr>
-          <a:xfrm>
-            <a:off x="8093004" y="4999484"/>
-            <a:ext cx="914400" cy="914400"/>
-          </a:xfrm>
-          <a:prstGeom prst="ellipse">
-            <a:avLst/>
-          </a:prstGeom>
-          <a:solidFill>
-            <a:schemeClr val="tx1"/>
-          </a:solidFill>
-          <a:ln>
-            <a:solidFill>
-              <a:srgbClr val="FFC000"/>
-            </a:solidFill>
-          </a:ln>
-        </p:spPr>
-        <p:style>
-          <a:lnRef idx="2">
-            <a:schemeClr val="accent1">
-              <a:shade val="15000"/>
-            </a:schemeClr>
-          </a:lnRef>
-          <a:fillRef idx="1">
-            <a:schemeClr val="accent1"/>
-          </a:fillRef>
-          <a:effectRef idx="0">
-            <a:schemeClr val="accent1"/>
-          </a:effectRef>
-          <a:fontRef idx="minor">
-            <a:schemeClr val="lt1"/>
-          </a:fontRef>
-        </p:style>
-        <p:txBody>
-          <a:bodyPr rtlCol="0" anchor="ctr"/>
-          <a:lstStyle/>
-          <a:p>
-            <a:pPr algn="ctr"/>
-            <a:endParaRPr lang="de-DE"/>
-          </a:p>
-        </p:txBody>
-      </p:sp>
-      <p:sp>
-        <p:nvSpPr>
           <p:cNvPr id="20" name="Oval 19">
             <a:extLst>
               <a:ext uri="{FF2B5EF4-FFF2-40B4-BE49-F238E27FC236}">
@@ -21399,10 +21291,10 @@
       </p:sp>
       <p:sp>
         <p:nvSpPr>
-          <p:cNvPr id="146" name="!!T2S">
-            <a:extLst>
-              <a:ext uri="{FF2B5EF4-FFF2-40B4-BE49-F238E27FC236}">
-                <a16:creationId xmlns:a16="http://schemas.microsoft.com/office/drawing/2014/main" id="{D4F492A8-21D1-F662-62D0-8916B4FE5A6B}"/>
+          <p:cNvPr id="144" name="!!T3S">
+            <a:extLst>
+              <a:ext uri="{FF2B5EF4-FFF2-40B4-BE49-F238E27FC236}">
+                <a16:creationId xmlns:a16="http://schemas.microsoft.com/office/drawing/2014/main" id="{08941A4F-8AD0-793D-8854-42DF0AFD48BB}"/>
               </a:ext>
             </a:extLst>
           </p:cNvPr>
@@ -21411,8 +21303,8 @@
         </p:nvSpPr>
         <p:spPr>
           <a:xfrm>
-            <a:off x="0" y="1142576"/>
-            <a:ext cx="5406190" cy="3606238"/>
+            <a:off x="-1" y="2551212"/>
+            <a:ext cx="6506062" cy="5200492"/>
           </a:xfrm>
           <a:custGeom>
             <a:avLst/>
@@ -21442,7 +21334,7 @@
             </a:pathLst>
           </a:custGeom>
           <a:blipFill rotWithShape="1">
-            <a:blip r:embed="rId3">
+            <a:blip>
               <a:alphaModFix/>
             </a:blip>
             <a:stretch>
@@ -21457,16 +21349,16 @@
           <a:bodyPr/>
           <a:lstStyle/>
           <a:p>
-            <a:endParaRPr lang="de-DE"/>
-          </a:p>
-        </p:txBody>
-      </p:sp>
-      <p:sp>
-        <p:nvSpPr>
-          <p:cNvPr id="144" name="!!T3S">
-            <a:extLst>
-              <a:ext uri="{FF2B5EF4-FFF2-40B4-BE49-F238E27FC236}">
-                <a16:creationId xmlns:a16="http://schemas.microsoft.com/office/drawing/2014/main" id="{08941A4F-8AD0-793D-8854-42DF0AFD48BB}"/>
+            <a:endParaRPr lang="de-DE" dirty="0"/>
+          </a:p>
+        </p:txBody>
+      </p:sp>
+      <p:sp>
+        <p:nvSpPr>
+          <p:cNvPr id="2" name="!!T1S">
+            <a:extLst>
+              <a:ext uri="{FF2B5EF4-FFF2-40B4-BE49-F238E27FC236}">
+                <a16:creationId xmlns:a16="http://schemas.microsoft.com/office/drawing/2014/main" id="{6DE012AE-7998-3019-E156-2EFB6C52B131}"/>
               </a:ext>
             </a:extLst>
           </p:cNvPr>
@@ -21475,8 +21367,8 @@
         </p:nvSpPr>
         <p:spPr>
           <a:xfrm>
-            <a:off x="-1" y="2551212"/>
-            <a:ext cx="6506062" cy="5200492"/>
+            <a:off x="0" y="128484"/>
+            <a:ext cx="3609474" cy="2470111"/>
           </a:xfrm>
           <a:custGeom>
             <a:avLst/>
@@ -21506,7 +21398,7 @@
             </a:pathLst>
           </a:custGeom>
           <a:blipFill rotWithShape="1">
-            <a:blip r:embed="rId3">
+            <a:blip>
               <a:alphaModFix/>
             </a:blip>
             <a:stretch>
@@ -21521,16 +21413,16 @@
           <a:bodyPr/>
           <a:lstStyle/>
           <a:p>
-            <a:endParaRPr lang="de-DE" dirty="0"/>
-          </a:p>
-        </p:txBody>
-      </p:sp>
-      <p:sp>
-        <p:nvSpPr>
-          <p:cNvPr id="2" name="!!T1S">
-            <a:extLst>
-              <a:ext uri="{FF2B5EF4-FFF2-40B4-BE49-F238E27FC236}">
-                <a16:creationId xmlns:a16="http://schemas.microsoft.com/office/drawing/2014/main" id="{6DE012AE-7998-3019-E156-2EFB6C52B131}"/>
+            <a:endParaRPr lang="de-DE"/>
+          </a:p>
+        </p:txBody>
+      </p:sp>
+      <p:sp>
+        <p:nvSpPr>
+          <p:cNvPr id="7" name="!!T4S">
+            <a:extLst>
+              <a:ext uri="{FF2B5EF4-FFF2-40B4-BE49-F238E27FC236}">
+                <a16:creationId xmlns:a16="http://schemas.microsoft.com/office/drawing/2014/main" id="{C83770C8-364F-03D4-2532-B5162D4F1B1C}"/>
               </a:ext>
             </a:extLst>
           </p:cNvPr>
@@ -21539,8 +21431,8 @@
         </p:nvSpPr>
         <p:spPr>
           <a:xfrm>
-            <a:off x="0" y="128484"/>
-            <a:ext cx="3609474" cy="2470111"/>
+            <a:off x="31916" y="5422664"/>
+            <a:ext cx="5406190" cy="3606238"/>
           </a:xfrm>
           <a:custGeom>
             <a:avLst/>
@@ -21570,71 +21462,7 @@
             </a:pathLst>
           </a:custGeom>
           <a:blipFill rotWithShape="1">
-            <a:blip r:embed="rId3">
-              <a:alphaModFix/>
-            </a:blip>
-            <a:stretch>
-              <a:fillRect l="-137270"/>
-            </a:stretch>
-          </a:blipFill>
-          <a:ln>
-            <a:noFill/>
-          </a:ln>
-        </p:spPr>
-        <p:txBody>
-          <a:bodyPr/>
-          <a:lstStyle/>
-          <a:p>
-            <a:endParaRPr lang="de-DE"/>
-          </a:p>
-        </p:txBody>
-      </p:sp>
-      <p:sp>
-        <p:nvSpPr>
-          <p:cNvPr id="7" name="!!T4S">
-            <a:extLst>
-              <a:ext uri="{FF2B5EF4-FFF2-40B4-BE49-F238E27FC236}">
-                <a16:creationId xmlns:a16="http://schemas.microsoft.com/office/drawing/2014/main" id="{C83770C8-364F-03D4-2532-B5162D4F1B1C}"/>
-              </a:ext>
-            </a:extLst>
-          </p:cNvPr>
-          <p:cNvSpPr/>
-          <p:nvPr/>
-        </p:nvSpPr>
-        <p:spPr>
-          <a:xfrm>
-            <a:off x="31916" y="5422664"/>
-            <a:ext cx="5406190" cy="3606238"/>
-          </a:xfrm>
-          <a:custGeom>
-            <a:avLst/>
-            <a:gdLst/>
-            <a:ahLst/>
-            <a:cxnLst/>
-            <a:rect l="l" t="t" r="r" b="b"/>
-            <a:pathLst>
-              <a:path w="13810523" h="4792440" extrusionOk="0">
-                <a:moveTo>
-                  <a:pt x="0" y="0"/>
-                </a:moveTo>
-                <a:lnTo>
-                  <a:pt x="13810523" y="0"/>
-                </a:lnTo>
-                <a:lnTo>
-                  <a:pt x="13810523" y="4792440"/>
-                </a:lnTo>
-                <a:lnTo>
-                  <a:pt x="0" y="4792440"/>
-                </a:lnTo>
-                <a:lnTo>
-                  <a:pt x="0" y="0"/>
-                </a:lnTo>
-                <a:close/>
-              </a:path>
-            </a:pathLst>
-          </a:custGeom>
-          <a:blipFill rotWithShape="1">
-            <a:blip r:embed="rId3">
+            <a:blip>
               <a:alphaModFix/>
             </a:blip>
             <a:stretch>
@@ -22578,6 +22406,242 @@
           <a:lstStyle/>
           <a:p>
             <a:pPr algn="ctr"/>
+            <a:endParaRPr lang="de-DE"/>
+          </a:p>
+        </p:txBody>
+      </p:sp>
+      <p:sp>
+        <p:nvSpPr>
+          <p:cNvPr id="13" name="!!T12S">
+            <a:extLst>
+              <a:ext uri="{FF2B5EF4-FFF2-40B4-BE49-F238E27FC236}">
+                <a16:creationId xmlns:a16="http://schemas.microsoft.com/office/drawing/2014/main" id="{38E42909-9129-A563-29BA-D079141F8EAE}"/>
+              </a:ext>
+            </a:extLst>
+          </p:cNvPr>
+          <p:cNvSpPr/>
+          <p:nvPr/>
+        </p:nvSpPr>
+        <p:spPr>
+          <a:xfrm>
+            <a:off x="0" y="7506543"/>
+            <a:ext cx="3609474" cy="2470111"/>
+          </a:xfrm>
+          <a:custGeom>
+            <a:avLst/>
+            <a:gdLst/>
+            <a:ahLst/>
+            <a:cxnLst/>
+            <a:rect l="l" t="t" r="r" b="b"/>
+            <a:pathLst>
+              <a:path w="13810523" h="4792440" extrusionOk="0">
+                <a:moveTo>
+                  <a:pt x="0" y="0"/>
+                </a:moveTo>
+                <a:lnTo>
+                  <a:pt x="13810523" y="0"/>
+                </a:lnTo>
+                <a:lnTo>
+                  <a:pt x="13810523" y="4792440"/>
+                </a:lnTo>
+                <a:lnTo>
+                  <a:pt x="0" y="4792440"/>
+                </a:lnTo>
+                <a:lnTo>
+                  <a:pt x="0" y="0"/>
+                </a:lnTo>
+                <a:close/>
+              </a:path>
+            </a:pathLst>
+          </a:custGeom>
+          <a:blipFill rotWithShape="1">
+            <a:blip>
+              <a:alphaModFix/>
+            </a:blip>
+            <a:stretch>
+              <a:fillRect l="-137270"/>
+            </a:stretch>
+          </a:blipFill>
+          <a:ln>
+            <a:noFill/>
+          </a:ln>
+        </p:spPr>
+        <p:txBody>
+          <a:bodyPr/>
+          <a:lstStyle/>
+          <a:p>
+            <a:endParaRPr lang="de-DE"/>
+          </a:p>
+        </p:txBody>
+      </p:sp>
+      <p:sp>
+        <p:nvSpPr>
+          <p:cNvPr id="18" name="Oval 17">
+            <a:extLst>
+              <a:ext uri="{FF2B5EF4-FFF2-40B4-BE49-F238E27FC236}">
+                <a16:creationId xmlns:a16="http://schemas.microsoft.com/office/drawing/2014/main" id="{1FED2717-B14C-8925-BC98-E5EDB3D4B940}"/>
+              </a:ext>
+            </a:extLst>
+          </p:cNvPr>
+          <p:cNvSpPr/>
+          <p:nvPr/>
+        </p:nvSpPr>
+        <p:spPr>
+          <a:xfrm>
+            <a:off x="6455988" y="5017451"/>
+            <a:ext cx="914400" cy="914400"/>
+          </a:xfrm>
+          <a:prstGeom prst="ellipse">
+            <a:avLst/>
+          </a:prstGeom>
+          <a:solidFill>
+            <a:schemeClr val="tx1"/>
+          </a:solidFill>
+          <a:ln>
+            <a:solidFill>
+              <a:srgbClr val="FFC000"/>
+            </a:solidFill>
+          </a:ln>
+        </p:spPr>
+        <p:style>
+          <a:lnRef idx="2">
+            <a:schemeClr val="accent1">
+              <a:shade val="15000"/>
+            </a:schemeClr>
+          </a:lnRef>
+          <a:fillRef idx="1">
+            <a:schemeClr val="accent1"/>
+          </a:fillRef>
+          <a:effectRef idx="0">
+            <a:schemeClr val="accent1"/>
+          </a:effectRef>
+          <a:fontRef idx="minor">
+            <a:schemeClr val="lt1"/>
+          </a:fontRef>
+        </p:style>
+        <p:txBody>
+          <a:bodyPr rtlCol="0" anchor="ctr"/>
+          <a:lstStyle/>
+          <a:p>
+            <a:pPr algn="ctr"/>
+            <a:endParaRPr lang="de-DE"/>
+          </a:p>
+        </p:txBody>
+      </p:sp>
+      <p:sp>
+        <p:nvSpPr>
+          <p:cNvPr id="19" name="Oval 18">
+            <a:extLst>
+              <a:ext uri="{FF2B5EF4-FFF2-40B4-BE49-F238E27FC236}">
+                <a16:creationId xmlns:a16="http://schemas.microsoft.com/office/drawing/2014/main" id="{A1A1A19E-0F5A-7EFC-B37B-5D654D7AED9F}"/>
+              </a:ext>
+            </a:extLst>
+          </p:cNvPr>
+          <p:cNvSpPr/>
+          <p:nvPr/>
+        </p:nvSpPr>
+        <p:spPr>
+          <a:xfrm>
+            <a:off x="8093004" y="4999484"/>
+            <a:ext cx="914400" cy="914400"/>
+          </a:xfrm>
+          <a:prstGeom prst="ellipse">
+            <a:avLst/>
+          </a:prstGeom>
+          <a:solidFill>
+            <a:schemeClr val="tx1"/>
+          </a:solidFill>
+          <a:ln>
+            <a:solidFill>
+              <a:srgbClr val="FFC000"/>
+            </a:solidFill>
+          </a:ln>
+        </p:spPr>
+        <p:style>
+          <a:lnRef idx="2">
+            <a:schemeClr val="accent1">
+              <a:shade val="15000"/>
+            </a:schemeClr>
+          </a:lnRef>
+          <a:fillRef idx="1">
+            <a:schemeClr val="accent1"/>
+          </a:fillRef>
+          <a:effectRef idx="0">
+            <a:schemeClr val="accent1"/>
+          </a:effectRef>
+          <a:fontRef idx="minor">
+            <a:schemeClr val="lt1"/>
+          </a:fontRef>
+        </p:style>
+        <p:txBody>
+          <a:bodyPr rtlCol="0" anchor="ctr"/>
+          <a:lstStyle/>
+          <a:p>
+            <a:pPr algn="ctr"/>
+            <a:endParaRPr lang="de-DE"/>
+          </a:p>
+        </p:txBody>
+      </p:sp>
+      <p:sp>
+        <p:nvSpPr>
+          <p:cNvPr id="146" name="!!T2S">
+            <a:extLst>
+              <a:ext uri="{FF2B5EF4-FFF2-40B4-BE49-F238E27FC236}">
+                <a16:creationId xmlns:a16="http://schemas.microsoft.com/office/drawing/2014/main" id="{D4F492A8-21D1-F662-62D0-8916B4FE5A6B}"/>
+              </a:ext>
+            </a:extLst>
+          </p:cNvPr>
+          <p:cNvSpPr/>
+          <p:nvPr/>
+        </p:nvSpPr>
+        <p:spPr>
+          <a:xfrm>
+            <a:off x="0" y="1142576"/>
+            <a:ext cx="5406190" cy="3606238"/>
+          </a:xfrm>
+          <a:custGeom>
+            <a:avLst/>
+            <a:gdLst/>
+            <a:ahLst/>
+            <a:cxnLst/>
+            <a:rect l="l" t="t" r="r" b="b"/>
+            <a:pathLst>
+              <a:path w="13810523" h="4792440" extrusionOk="0">
+                <a:moveTo>
+                  <a:pt x="0" y="0"/>
+                </a:moveTo>
+                <a:lnTo>
+                  <a:pt x="13810523" y="0"/>
+                </a:lnTo>
+                <a:lnTo>
+                  <a:pt x="13810523" y="4792440"/>
+                </a:lnTo>
+                <a:lnTo>
+                  <a:pt x="0" y="4792440"/>
+                </a:lnTo>
+                <a:lnTo>
+                  <a:pt x="0" y="0"/>
+                </a:lnTo>
+                <a:close/>
+              </a:path>
+            </a:pathLst>
+          </a:custGeom>
+          <a:blipFill rotWithShape="1">
+            <a:blip>
+              <a:alphaModFix/>
+            </a:blip>
+            <a:stretch>
+              <a:fillRect l="-137270"/>
+            </a:stretch>
+          </a:blipFill>
+          <a:ln>
+            <a:noFill/>
+          </a:ln>
+        </p:spPr>
+        <p:txBody>
+          <a:bodyPr/>
+          <a:lstStyle/>
+          <a:p>
             <a:endParaRPr lang="de-DE"/>
           </a:p>
         </p:txBody>
@@ -22774,7 +22838,7 @@
             </a:pathLst>
           </a:custGeom>
           <a:blipFill rotWithShape="1">
-            <a:blip r:embed="rId3">
+            <a:blip>
               <a:alphaModFix/>
             </a:blip>
             <a:stretch>
@@ -22838,7 +22902,7 @@
             </a:pathLst>
           </a:custGeom>
           <a:blipFill rotWithShape="1">
-            <a:blip r:embed="rId3">
+            <a:blip>
               <a:alphaModFix/>
             </a:blip>
             <a:stretch>
@@ -22902,7 +22966,7 @@
             </a:pathLst>
           </a:custGeom>
           <a:blipFill rotWithShape="1">
-            <a:blip r:embed="rId3">
+            <a:blip>
               <a:alphaModFix/>
             </a:blip>
             <a:stretch>
@@ -24028,7 +24092,7 @@
             </a:pathLst>
           </a:custGeom>
           <a:blipFill rotWithShape="1">
-            <a:blip r:embed="rId3">
+            <a:blip>
               <a:alphaModFix/>
             </a:blip>
             <a:stretch>
@@ -24092,7 +24156,7 @@
             </a:pathLst>
           </a:custGeom>
           <a:blipFill rotWithShape="1">
-            <a:blip r:embed="rId3">
+            <a:blip>
               <a:alphaModFix/>
             </a:blip>
             <a:stretch>
@@ -24156,7 +24220,7 @@
             </a:pathLst>
           </a:custGeom>
           <a:blipFill rotWithShape="1">
-            <a:blip r:embed="rId3">
+            <a:blip>
               <a:alphaModFix/>
             </a:blip>
             <a:stretch>
@@ -24350,7 +24414,7 @@
             </a:pathLst>
           </a:custGeom>
           <a:blipFill rotWithShape="1">
-            <a:blip r:embed="rId3">
+            <a:blip>
               <a:alphaModFix/>
             </a:blip>
             <a:stretch>
@@ -25711,7 +25775,7 @@
             </a:pathLst>
           </a:custGeom>
           <a:blipFill rotWithShape="1">
-            <a:blip r:embed="rId3">
+            <a:blip>
               <a:alphaModFix/>
             </a:blip>
             <a:stretch>
@@ -25838,7 +25902,7 @@
             </a:pathLst>
           </a:custGeom>
           <a:blipFill rotWithShape="1">
-            <a:blip r:embed="rId3">
+            <a:blip>
               <a:alphaModFix/>
             </a:blip>
             <a:stretch>
@@ -25969,7 +26033,7 @@
             </a:pathLst>
           </a:custGeom>
           <a:blipFill rotWithShape="1">
-            <a:blip r:embed="rId3">
+            <a:blip>
               <a:alphaModFix/>
             </a:blip>
             <a:stretch>
@@ -26033,7 +26097,7 @@
             </a:pathLst>
           </a:custGeom>
           <a:blipFill rotWithShape="1">
-            <a:blip r:embed="rId3">
+            <a:blip>
               <a:alphaModFix/>
             </a:blip>
             <a:stretch>
@@ -27099,7 +27163,7 @@
           <p:nvPr/>
         </p:nvPicPr>
         <p:blipFill>
-          <a:blip r:embed="rId3"/>
+          <a:blip/>
           <a:stretch>
             <a:fillRect/>
           </a:stretch>
@@ -27159,7 +27223,7 @@
             </a:pathLst>
           </a:custGeom>
           <a:blipFill rotWithShape="1">
-            <a:blip r:embed="rId4">
+            <a:blip>
               <a:alphaModFix/>
             </a:blip>
             <a:stretch>
@@ -27223,7 +27287,7 @@
             </a:pathLst>
           </a:custGeom>
           <a:blipFill rotWithShape="1">
-            <a:blip r:embed="rId4">
+            <a:blip>
               <a:alphaModFix/>
             </a:blip>
             <a:stretch>
@@ -27344,7 +27408,7 @@
             </a:pathLst>
           </a:custGeom>
           <a:blipFill rotWithShape="1">
-            <a:blip r:embed="rId4">
+            <a:blip>
               <a:alphaModFix/>
             </a:blip>
             <a:stretch>
@@ -28916,7 +28980,7 @@
             </a:pathLst>
           </a:custGeom>
           <a:blipFill rotWithShape="1">
-            <a:blip r:embed="rId3">
+            <a:blip>
               <a:alphaModFix/>
             </a:blip>
             <a:stretch>
@@ -29108,7 +29172,7 @@
             </a:pathLst>
           </a:custGeom>
           <a:blipFill rotWithShape="1">
-            <a:blip r:embed="rId3">
+            <a:blip>
               <a:alphaModFix/>
             </a:blip>
             <a:stretch>
@@ -29300,7 +29364,7 @@
             </a:pathLst>
           </a:custGeom>
           <a:blipFill rotWithShape="1">
-            <a:blip r:embed="rId3">
+            <a:blip>
               <a:alphaModFix/>
             </a:blip>
             <a:stretch>
@@ -29490,7 +29554,7 @@
             </a:pathLst>
           </a:custGeom>
           <a:blipFill rotWithShape="1">
-            <a:blip r:embed="rId3">
+            <a:blip>
               <a:alphaModFix/>
             </a:blip>
             <a:stretch>
@@ -29682,7 +29746,7 @@
             </a:pathLst>
           </a:custGeom>
           <a:blipFill rotWithShape="1">
-            <a:blip r:embed="rId3">
+            <a:blip>
               <a:alphaModFix/>
             </a:blip>
             <a:stretch>
@@ -31068,7 +31132,7 @@
             </a:pathLst>
           </a:custGeom>
           <a:blipFill rotWithShape="1">
-            <a:blip r:embed="rId3">
+            <a:blip>
               <a:alphaModFix/>
             </a:blip>
             <a:stretch>
@@ -31132,7 +31196,7 @@
             </a:pathLst>
           </a:custGeom>
           <a:blipFill rotWithShape="1">
-            <a:blip r:embed="rId3">
+            <a:blip>
               <a:alphaModFix/>
             </a:blip>
             <a:stretch>
@@ -31324,7 +31388,7 @@
             </a:pathLst>
           </a:custGeom>
           <a:blipFill rotWithShape="1">
-            <a:blip r:embed="rId3">
+            <a:blip>
               <a:alphaModFix/>
             </a:blip>
             <a:stretch>
@@ -31514,7 +31578,7 @@
             </a:pathLst>
           </a:custGeom>
           <a:blipFill rotWithShape="1">
-            <a:blip r:embed="rId3">
+            <a:blip>
               <a:alphaModFix/>
             </a:blip>
             <a:stretch>
@@ -31708,7 +31772,7 @@
             </a:pathLst>
           </a:custGeom>
           <a:blipFill rotWithShape="1">
-            <a:blip r:embed="rId3">
+            <a:blip>
               <a:alphaModFix/>
             </a:blip>
             <a:stretch>
@@ -33295,7 +33359,7 @@
             </a:pathLst>
           </a:custGeom>
           <a:blipFill rotWithShape="1">
-            <a:blip r:embed="rId3">
+            <a:blip>
               <a:alphaModFix/>
             </a:blip>
             <a:stretch>
@@ -33359,7 +33423,7 @@
             </a:pathLst>
           </a:custGeom>
           <a:blipFill rotWithShape="1">
-            <a:blip r:embed="rId3">
+            <a:blip>
               <a:alphaModFix/>
             </a:blip>
             <a:stretch>
@@ -33423,7 +33487,7 @@
             </a:pathLst>
           </a:custGeom>
           <a:blipFill rotWithShape="1">
-            <a:blip r:embed="rId3">
+            <a:blip>
               <a:alphaModFix/>
             </a:blip>
             <a:stretch>
@@ -33613,7 +33677,7 @@
             </a:pathLst>
           </a:custGeom>
           <a:blipFill rotWithShape="1">
-            <a:blip r:embed="rId3">
+            <a:blip>
               <a:alphaModFix/>
             </a:blip>
             <a:stretch>
@@ -33807,7 +33871,7 @@
             </a:pathLst>
           </a:custGeom>
           <a:blipFill rotWithShape="1">
-            <a:blip r:embed="rId3">
+            <a:blip>
               <a:alphaModFix/>
             </a:blip>
             <a:stretch>
@@ -35549,7 +35613,7 @@
             </a:pathLst>
           </a:custGeom>
           <a:blipFill rotWithShape="1">
-            <a:blip r:embed="rId3">
+            <a:blip>
               <a:alphaModFix/>
             </a:blip>
             <a:stretch>
@@ -35613,7 +35677,7 @@
             </a:pathLst>
           </a:custGeom>
           <a:blipFill rotWithShape="1">
-            <a:blip r:embed="rId3">
+            <a:blip>
               <a:alphaModFix/>
             </a:blip>
             <a:stretch>
@@ -35805,7 +35869,7 @@
             </a:pathLst>
           </a:custGeom>
           <a:blipFill rotWithShape="1">
-            <a:blip r:embed="rId3">
+            <a:blip>
               <a:alphaModFix/>
             </a:blip>
             <a:stretch>
@@ -35995,7 +36059,7 @@
             </a:pathLst>
           </a:custGeom>
           <a:blipFill rotWithShape="1">
-            <a:blip r:embed="rId3">
+            <a:blip>
               <a:alphaModFix/>
             </a:blip>
             <a:stretch>
@@ -36189,7 +36253,7 @@
             </a:pathLst>
           </a:custGeom>
           <a:blipFill rotWithShape="1">
-            <a:blip r:embed="rId3">
+            <a:blip>
               <a:alphaModFix/>
             </a:blip>
             <a:stretch>

</xml_diff>